<commit_message>
Cut the presentation to six slides
Ten was more than a manager needs. The deck now runs result, architecture, the
hardest problem, the reasoning, and reliability. The layer breakdown and the two
mechanism diagrams stay in the PDF for anyone who asks for detail.

Co-Authored-By: Claude Opus 5 <noreply@anthropic.com>
</commit_message>
<xml_diff>
--- a/docs/OpenEMR-ovozli-yozuv.pptx
+++ b/docs/OpenEMR-ovozli-yozuv.pptx
@@ -11,10 +11,6 @@
     <p:sldId id="259" r:id="rId10"/>
     <p:sldId id="260" r:id="rId11"/>
     <p:sldId id="261" r:id="rId12"/>
-    <p:sldId id="262" r:id="rId13"/>
-    <p:sldId id="263" r:id="rId14"/>
-    <p:sldId id="264" r:id="rId15"/>
-    <p:sldId id="265" r:id="rId16"/>
   </p:sldIdLst>
   <p:sldSz cx="12191695" cy="6858000" type="screen4x3"/>
   <p:notesSz cx="6858000" cy="9144000"/>
@@ -3149,8 +3145,8 @@
         </p:nvSpPr>
         <p:spPr>
           <a:xfrm>
-            <a:off x="777240" y="2057400"/>
-            <a:ext cx="10607040" cy="457200"/>
+            <a:off x="777240" y="2103120"/>
+            <a:ext cx="10607040" cy="365760"/>
           </a:xfrm>
           <a:prstGeom prst="rect">
             <a:avLst/>
@@ -3165,7 +3161,7 @@
           <a:p>
             <a:pPr algn="l">
               <a:spcAft>
-                <a:spcPts val="600"/>
+                <a:spcPts val="700"/>
               </a:spcAft>
             </a:pPr>
             <a:r>
@@ -3188,8 +3184,8 @@
         </p:nvSpPr>
         <p:spPr>
           <a:xfrm>
-            <a:off x="777240" y="2514600"/>
-            <a:ext cx="10607040" cy="1280160"/>
+            <a:off x="777240" y="2560320"/>
+            <a:ext cx="10607040" cy="1188720"/>
           </a:xfrm>
           <a:prstGeom prst="rect">
             <a:avLst/>
@@ -3204,7 +3200,7 @@
           <a:p>
             <a:pPr algn="l">
               <a:spcAft>
-                <a:spcPts val="600"/>
+                <a:spcPts val="700"/>
               </a:spcAft>
             </a:pPr>
             <a:r>
@@ -3227,8 +3223,8 @@
         </p:nvSpPr>
         <p:spPr>
           <a:xfrm>
-            <a:off x="777240" y="3794760"/>
-            <a:ext cx="9601200" cy="1097280"/>
+            <a:off x="777240" y="3840480"/>
+            <a:ext cx="9601200" cy="1005840"/>
           </a:xfrm>
           <a:prstGeom prst="rect">
             <a:avLst/>
@@ -3243,7 +3239,7 @@
           <a:p>
             <a:pPr algn="l">
               <a:spcAft>
-                <a:spcPts val="600"/>
+                <a:spcPts val="700"/>
               </a:spcAft>
             </a:pPr>
             <a:r>
@@ -3259,7 +3255,7 @@
           <a:p>
             <a:pPr algn="l">
               <a:spcAft>
-                <a:spcPts val="600"/>
+                <a:spcPts val="700"/>
               </a:spcAft>
             </a:pPr>
             <a:r>
@@ -3282,7 +3278,7 @@
         </p:nvSpPr>
         <p:spPr>
           <a:xfrm>
-            <a:off x="777240" y="5760720"/>
+            <a:off x="777240" y="5806440"/>
             <a:ext cx="10607040" cy="365760"/>
           </a:xfrm>
           <a:prstGeom prst="rect">
@@ -3298,7 +3294,7 @@
           <a:p>
             <a:pPr algn="l">
               <a:spcAft>
-                <a:spcPts val="600"/>
+                <a:spcPts val="700"/>
               </a:spcAft>
             </a:pPr>
             <a:r>
@@ -3309,201 +3305,6 @@
                 <a:latin typeface="Helvetica Neue"/>
               </a:rPr>
               <a:t>Tohirjon Vohidov</a:t>
-            </a:r>
-          </a:p>
-        </p:txBody>
-      </p:sp>
-    </p:spTree>
-  </p:cSld>
-  <p:clrMapOvr>
-    <a:masterClrMapping/>
-  </p:clrMapOvr>
-</p:sld>
-</file>
-
-<file path=ppt/slides/slide10.xml><?xml version="1.0" encoding="utf-8"?>
-<p:sld xmlns:a="http://schemas.openxmlformats.org/drawingml/2006/main" xmlns:p="http://schemas.openxmlformats.org/presentationml/2006/main" xmlns:r="http://schemas.openxmlformats.org/officeDocument/2006/relationships">
-  <p:cSld>
-    <p:spTree>
-      <p:nvGrpSpPr>
-        <p:cNvPr id="1" name=""/>
-        <p:cNvGrpSpPr/>
-        <p:nvPr/>
-      </p:nvGrpSpPr>
-      <p:grpSpPr/>
-      <p:sp>
-        <p:nvSpPr>
-          <p:cNvPr id="2" name="Rectangle 1"/>
-          <p:cNvSpPr/>
-          <p:nvPr/>
-        </p:nvSpPr>
-        <p:spPr>
-          <a:xfrm>
-            <a:off x="0" y="0"/>
-            <a:ext cx="12191695" cy="6858000"/>
-          </a:xfrm>
-          <a:prstGeom prst="rect">
-            <a:avLst/>
-          </a:prstGeom>
-          <a:solidFill>
-            <a:srgbClr val="F6F7F4"/>
-          </a:solidFill>
-          <a:ln>
-            <a:noFill/>
-          </a:ln>
-          <a:effectLst/>
-        </p:spPr>
-        <p:style>
-          <a:lnRef idx="1">
-            <a:schemeClr val="accent1"/>
-          </a:lnRef>
-          <a:fillRef idx="3">
-            <a:schemeClr val="accent1"/>
-          </a:fillRef>
-          <a:effectRef idx="2">
-            <a:schemeClr val="accent1"/>
-          </a:effectRef>
-          <a:fontRef idx="minor">
-            <a:schemeClr val="lt1"/>
-          </a:fontRef>
-        </p:style>
-        <p:txBody>
-          <a:bodyPr rtlCol="0" anchor="ctr"/>
-          <a:lstStyle/>
-          <a:p>
-            <a:pPr algn="ctr"/>
-          </a:p>
-        </p:txBody>
-      </p:sp>
-      <p:sp>
-        <p:nvSpPr>
-          <p:cNvPr id="3" name="TextBox 2"/>
-          <p:cNvSpPr txBox="1"/>
-          <p:nvPr/>
-        </p:nvSpPr>
-        <p:spPr>
-          <a:xfrm>
-            <a:off x="777240" y="2377440"/>
-            <a:ext cx="10607040" cy="914400"/>
-          </a:xfrm>
-          <a:prstGeom prst="rect">
-            <a:avLst/>
-          </a:prstGeom>
-          <a:noFill/>
-        </p:spPr>
-        <p:txBody>
-          <a:bodyPr wrap="square" lIns="0" rIns="0" tIns="0" bIns="0">
-            <a:spAutoFit/>
-          </a:bodyPr>
-          <a:lstStyle/>
-          <a:p>
-            <a:pPr algn="l">
-              <a:spcAft>
-                <a:spcPts val="600"/>
-              </a:spcAft>
-            </a:pPr>
-            <a:r>
-              <a:rPr sz="4000" b="1">
-                <a:solidFill>
-                  <a:srgbClr val="131E19"/>
-                </a:solidFill>
-                <a:latin typeface="Helvetica Neue"/>
-              </a:rPr>
-              <a:t>Ishlaydigan tizim, o'lchangan natija</a:t>
-            </a:r>
-          </a:p>
-        </p:txBody>
-      </p:sp>
-      <p:sp>
-        <p:nvSpPr>
-          <p:cNvPr id="4" name="TextBox 3"/>
-          <p:cNvSpPr txBox="1"/>
-          <p:nvPr/>
-        </p:nvSpPr>
-        <p:spPr>
-          <a:xfrm>
-            <a:off x="777240" y="3566160"/>
-            <a:ext cx="10058400" cy="1463040"/>
-          </a:xfrm>
-          <a:prstGeom prst="rect">
-            <a:avLst/>
-          </a:prstGeom>
-          <a:noFill/>
-        </p:spPr>
-        <p:txBody>
-          <a:bodyPr wrap="square" lIns="0" rIns="0" tIns="0" bIns="0">
-            <a:spAutoFit/>
-          </a:bodyPr>
-          <a:lstStyle/>
-          <a:p>
-            <a:pPr algn="l">
-              <a:spcAft>
-                <a:spcPts val="600"/>
-              </a:spcAft>
-            </a:pPr>
-            <a:r>
-              <a:rPr sz="2200" b="0">
-                <a:solidFill>
-                  <a:srgbClr val="6E7D76"/>
-                </a:solidFill>
-                <a:latin typeface="Helvetica Neue"/>
-              </a:rPr>
-              <a:t>Ovozdan formagacha bo'lgan butun yo'l tayyor.</a:t>
-            </a:r>
-          </a:p>
-          <a:p>
-            <a:pPr algn="l">
-              <a:spcAft>
-                <a:spcPts val="600"/>
-              </a:spcAft>
-            </a:pPr>
-            <a:r>
-              <a:rPr sz="2200" b="0">
-                <a:solidFill>
-                  <a:srgbClr val="6E7D76"/>
-                </a:solidFill>
-                <a:latin typeface="Helvetica Neue"/>
-              </a:rPr>
-              <a:t>Dori nomlarini tanish 62 dan 88 foizga ko'tarildi, modelning o'zi o'zgarmasdan.</a:t>
-            </a:r>
-          </a:p>
-        </p:txBody>
-      </p:sp>
-      <p:sp>
-        <p:nvSpPr>
-          <p:cNvPr id="5" name="TextBox 4"/>
-          <p:cNvSpPr txBox="1"/>
-          <p:nvPr/>
-        </p:nvSpPr>
-        <p:spPr>
-          <a:xfrm>
-            <a:off x="777240" y="5760720"/>
-            <a:ext cx="10607040" cy="365760"/>
-          </a:xfrm>
-          <a:prstGeom prst="rect">
-            <a:avLst/>
-          </a:prstGeom>
-          <a:noFill/>
-        </p:spPr>
-        <p:txBody>
-          <a:bodyPr wrap="square" lIns="0" rIns="0" tIns="0" bIns="0">
-            <a:spAutoFit/>
-          </a:bodyPr>
-          <a:lstStyle/>
-          <a:p>
-            <a:pPr algn="l">
-              <a:spcAft>
-                <a:spcPts val="600"/>
-              </a:spcAft>
-            </a:pPr>
-            <a:r>
-              <a:rPr sz="1500" b="1">
-                <a:solidFill>
-                  <a:srgbClr val="0E6B58"/>
-                </a:solidFill>
-                <a:latin typeface="Helvetica Neue"/>
-              </a:rPr>
-              <a:t>github.com/VohidovTohirjon/voice-to-text-openemr</a:t>
             </a:r>
           </a:p>
         </p:txBody>
@@ -3578,7 +3379,7 @@
         </p:nvSpPr>
         <p:spPr>
           <a:xfrm>
-            <a:off x="777240" y="548640"/>
+            <a:off x="777240" y="566928"/>
             <a:ext cx="10607040" cy="822960"/>
           </a:xfrm>
           <a:prstGeom prst="rect">
@@ -3594,17 +3395,17 @@
           <a:p>
             <a:pPr algn="l">
               <a:spcAft>
-                <a:spcPts val="600"/>
+                <a:spcPts val="700"/>
               </a:spcAft>
             </a:pPr>
             <a:r>
-              <a:rPr sz="3400" b="1">
+              <a:rPr sz="3300" b="1">
                 <a:solidFill>
                   <a:srgbClr val="131E19"/>
                 </a:solidFill>
                 <a:latin typeface="Helvetica Neue"/>
               </a:rPr>
-              <a:t>Nima qilindi</a:t>
+              <a:t>Natija</a:t>
             </a:r>
           </a:p>
         </p:txBody>
@@ -3617,7 +3418,7 @@
         </p:nvSpPr>
         <p:spPr>
           <a:xfrm>
-            <a:off x="777240" y="1298448"/>
+            <a:off x="777240" y="1316736"/>
             <a:ext cx="10607040" cy="548640"/>
           </a:xfrm>
           <a:prstGeom prst="rect">
@@ -3633,7 +3434,7 @@
           <a:p>
             <a:pPr algn="l">
               <a:spcAft>
-                <a:spcPts val="600"/>
+                <a:spcPts val="700"/>
               </a:spcAft>
             </a:pPr>
             <a:r>
@@ -3656,8 +3457,8 @@
         </p:nvSpPr>
         <p:spPr>
           <a:xfrm>
-            <a:off x="777240" y="2194560"/>
-            <a:ext cx="2468880" cy="1828800"/>
+            <a:off x="777240" y="2286000"/>
+            <a:ext cx="2468880" cy="1920240"/>
           </a:xfrm>
           <a:prstGeom prst="roundRect">
             <a:avLst/>
@@ -3702,8 +3503,8 @@
         </p:nvSpPr>
         <p:spPr>
           <a:xfrm>
-            <a:off x="777240" y="2194560"/>
-            <a:ext cx="64008" cy="1828800"/>
+            <a:off x="777240" y="2286000"/>
+            <a:ext cx="64008" cy="1920240"/>
           </a:xfrm>
           <a:prstGeom prst="roundRect">
             <a:avLst/>
@@ -3746,7 +3547,7 @@
         </p:nvSpPr>
         <p:spPr>
           <a:xfrm>
-            <a:off x="1097280" y="2514600"/>
+            <a:off x="1124712" y="2633472"/>
             <a:ext cx="2011680" cy="731520"/>
           </a:xfrm>
           <a:prstGeom prst="rect">
@@ -3762,7 +3563,7 @@
           <a:p>
             <a:pPr algn="l">
               <a:spcAft>
-                <a:spcPts val="600"/>
+                <a:spcPts val="700"/>
               </a:spcAft>
             </a:pPr>
             <a:r>
@@ -3785,7 +3586,7 @@
         </p:nvSpPr>
         <p:spPr>
           <a:xfrm>
-            <a:off x="1097280" y="3246120"/>
+            <a:off x="1124712" y="3401568"/>
             <a:ext cx="2011680" cy="640080"/>
           </a:xfrm>
           <a:prstGeom prst="rect">
@@ -3801,7 +3602,7 @@
           <a:p>
             <a:pPr algn="l">
               <a:spcAft>
-                <a:spcPts val="600"/>
+                <a:spcPts val="700"/>
               </a:spcAft>
             </a:pPr>
             <a:r>
@@ -3824,8 +3625,8 @@
         </p:nvSpPr>
         <p:spPr>
           <a:xfrm>
-            <a:off x="3474720" y="2194560"/>
-            <a:ext cx="2468880" cy="1828800"/>
+            <a:off x="3474720" y="2286000"/>
+            <a:ext cx="2468880" cy="1920240"/>
           </a:xfrm>
           <a:prstGeom prst="roundRect">
             <a:avLst/>
@@ -3870,8 +3671,8 @@
         </p:nvSpPr>
         <p:spPr>
           <a:xfrm>
-            <a:off x="3474720" y="2194560"/>
-            <a:ext cx="64008" cy="1828800"/>
+            <a:off x="3474720" y="2286000"/>
+            <a:ext cx="64008" cy="1920240"/>
           </a:xfrm>
           <a:prstGeom prst="roundRect">
             <a:avLst/>
@@ -3914,7 +3715,7 @@
         </p:nvSpPr>
         <p:spPr>
           <a:xfrm>
-            <a:off x="3794760" y="2514600"/>
+            <a:off x="3822192" y="2633472"/>
             <a:ext cx="2011680" cy="731520"/>
           </a:xfrm>
           <a:prstGeom prst="rect">
@@ -3930,7 +3731,7 @@
           <a:p>
             <a:pPr algn="l">
               <a:spcAft>
-                <a:spcPts val="600"/>
+                <a:spcPts val="700"/>
               </a:spcAft>
             </a:pPr>
             <a:r>
@@ -3953,7 +3754,7 @@
         </p:nvSpPr>
         <p:spPr>
           <a:xfrm>
-            <a:off x="3794760" y="3246120"/>
+            <a:off x="3822192" y="3401568"/>
             <a:ext cx="2011680" cy="640080"/>
           </a:xfrm>
           <a:prstGeom prst="rect">
@@ -3969,7 +3770,7 @@
           <a:p>
             <a:pPr algn="l">
               <a:spcAft>
-                <a:spcPts val="600"/>
+                <a:spcPts val="700"/>
               </a:spcAft>
             </a:pPr>
             <a:r>
@@ -3992,8 +3793,8 @@
         </p:nvSpPr>
         <p:spPr>
           <a:xfrm>
-            <a:off x="6172200" y="2194560"/>
-            <a:ext cx="2468880" cy="1828800"/>
+            <a:off x="6172200" y="2286000"/>
+            <a:ext cx="2468880" cy="1920240"/>
           </a:xfrm>
           <a:prstGeom prst="roundRect">
             <a:avLst/>
@@ -4038,8 +3839,8 @@
         </p:nvSpPr>
         <p:spPr>
           <a:xfrm>
-            <a:off x="6172200" y="2194560"/>
-            <a:ext cx="64008" cy="1828800"/>
+            <a:off x="6172200" y="2286000"/>
+            <a:ext cx="64008" cy="1920240"/>
           </a:xfrm>
           <a:prstGeom prst="roundRect">
             <a:avLst/>
@@ -4082,7 +3883,7 @@
         </p:nvSpPr>
         <p:spPr>
           <a:xfrm>
-            <a:off x="6492240" y="2514600"/>
+            <a:off x="6519672" y="2633472"/>
             <a:ext cx="2011680" cy="731520"/>
           </a:xfrm>
           <a:prstGeom prst="rect">
@@ -4098,7 +3899,7 @@
           <a:p>
             <a:pPr algn="l">
               <a:spcAft>
-                <a:spcPts val="600"/>
+                <a:spcPts val="700"/>
               </a:spcAft>
             </a:pPr>
             <a:r>
@@ -4121,7 +3922,7 @@
         </p:nvSpPr>
         <p:spPr>
           <a:xfrm>
-            <a:off x="6492240" y="3246120"/>
+            <a:off x="6519672" y="3401568"/>
             <a:ext cx="2011680" cy="640080"/>
           </a:xfrm>
           <a:prstGeom prst="rect">
@@ -4137,7 +3938,7 @@
           <a:p>
             <a:pPr algn="l">
               <a:spcAft>
-                <a:spcPts val="600"/>
+                <a:spcPts val="700"/>
               </a:spcAft>
             </a:pPr>
             <a:r>
@@ -4160,8 +3961,8 @@
         </p:nvSpPr>
         <p:spPr>
           <a:xfrm>
-            <a:off x="8869680" y="2194560"/>
-            <a:ext cx="2468880" cy="1828800"/>
+            <a:off x="8869680" y="2286000"/>
+            <a:ext cx="2468880" cy="1920240"/>
           </a:xfrm>
           <a:prstGeom prst="roundRect">
             <a:avLst/>
@@ -4206,14 +4007,14 @@
         </p:nvSpPr>
         <p:spPr>
           <a:xfrm>
-            <a:off x="8869680" y="2194560"/>
-            <a:ext cx="64008" cy="1828800"/>
+            <a:off x="8869680" y="2286000"/>
+            <a:ext cx="64008" cy="1920240"/>
           </a:xfrm>
           <a:prstGeom prst="roundRect">
             <a:avLst/>
           </a:prstGeom>
           <a:solidFill>
-            <a:srgbClr val="A05007"/>
+            <a:srgbClr val="0E6B58"/>
           </a:solidFill>
           <a:ln>
             <a:noFill/>
@@ -4250,7 +4051,7 @@
         </p:nvSpPr>
         <p:spPr>
           <a:xfrm>
-            <a:off x="9189720" y="2514600"/>
+            <a:off x="9217152" y="2633472"/>
             <a:ext cx="2011680" cy="731520"/>
           </a:xfrm>
           <a:prstGeom prst="rect">
@@ -4266,13 +4067,13 @@
           <a:p>
             <a:pPr algn="l">
               <a:spcAft>
-                <a:spcPts val="600"/>
+                <a:spcPts val="700"/>
               </a:spcAft>
             </a:pPr>
             <a:r>
               <a:rPr sz="4000" b="1">
                 <a:solidFill>
-                  <a:srgbClr val="A05007"/>
+                  <a:srgbClr val="0E6B58"/>
                 </a:solidFill>
                 <a:latin typeface="Helvetica Neue"/>
               </a:rPr>
@@ -4289,7 +4090,7 @@
         </p:nvSpPr>
         <p:spPr>
           <a:xfrm>
-            <a:off x="9189720" y="3246120"/>
+            <a:off x="9217152" y="3401568"/>
             <a:ext cx="2011680" cy="640080"/>
           </a:xfrm>
           <a:prstGeom prst="rect">
@@ -4305,7 +4106,7 @@
           <a:p>
             <a:pPr algn="l">
               <a:spcAft>
-                <a:spcPts val="600"/>
+                <a:spcPts val="700"/>
               </a:spcAft>
             </a:pPr>
             <a:r>
@@ -4315,7 +4116,7 @@
                 </a:solidFill>
                 <a:latin typeface="Helvetica Neue"/>
               </a:rPr>
-              <a:t>ma'lumot bulutga chiqdi</a:t>
+              <a:t>bulutga yuborilgan ma'lumot</a:t>
             </a:r>
           </a:p>
         </p:txBody>
@@ -4328,8 +4129,8 @@
         </p:nvSpPr>
         <p:spPr>
           <a:xfrm>
-            <a:off x="777240" y="4617720"/>
-            <a:ext cx="10607040" cy="1463040"/>
+            <a:off x="777240" y="4846320"/>
+            <a:ext cx="10607040" cy="1280160"/>
           </a:xfrm>
           <a:prstGeom prst="rect">
             <a:avLst/>
@@ -4344,27 +4145,27 @@
           <a:p>
             <a:pPr algn="l">
               <a:spcAft>
-                <a:spcPts val="600"/>
+                <a:spcPts val="700"/>
               </a:spcAft>
             </a:pPr>
             <a:r>
-              <a:rPr sz="1900" b="0">
+              <a:rPr sz="2000" b="0">
                 <a:solidFill>
                   <a:srgbClr val="131E19"/>
                 </a:solidFill>
                 <a:latin typeface="Helvetica Neue"/>
               </a:rPr>
-              <a:t>SOAP bo'limlari, ko'rsatkichlar va tashxis kodi bir marta gapirishdan to'ldi.</a:t>
+              <a:t>SOAP bo'limlari, ko'rsatkichlar va tashxis kodi bir marta gapirishdan to'ladi.</a:t>
             </a:r>
           </a:p>
           <a:p>
             <a:pPr algn="l">
               <a:spcAft>
-                <a:spcPts val="600"/>
+                <a:spcPts val="700"/>
               </a:spcAft>
             </a:pPr>
             <a:r>
-              <a:rPr sz="1900" b="0">
+              <a:rPr sz="2000" b="0">
                 <a:solidFill>
                   <a:srgbClr val="131E19"/>
                 </a:solidFill>
@@ -4445,7 +4246,7 @@
         </p:nvSpPr>
         <p:spPr>
           <a:xfrm>
-            <a:off x="777240" y="548640"/>
+            <a:off x="777240" y="566928"/>
             <a:ext cx="10607040" cy="822960"/>
           </a:xfrm>
           <a:prstGeom prst="rect">
@@ -4461,17 +4262,17 @@
           <a:p>
             <a:pPr algn="l">
               <a:spcAft>
-                <a:spcPts val="600"/>
+                <a:spcPts val="700"/>
               </a:spcAft>
             </a:pPr>
             <a:r>
-              <a:rPr sz="3400" b="1">
+              <a:rPr sz="3300" b="1">
                 <a:solidFill>
                   <a:srgbClr val="131E19"/>
                 </a:solidFill>
                 <a:latin typeface="Helvetica Neue"/>
               </a:rPr>
-              <a:t>Arxitektura</a:t>
+              <a:t>Qanday ishlaydi</a:t>
             </a:r>
           </a:p>
         </p:txBody>
@@ -4492,8 +4293,8 @@
         </p:blipFill>
         <p:spPr>
           <a:xfrm>
-            <a:off x="2212847" y="1874519"/>
-            <a:ext cx="7735824" cy="4297680"/>
+            <a:off x="2295144" y="1874519"/>
+            <a:ext cx="7571231" cy="4206240"/>
           </a:xfrm>
           <a:prstGeom prst="rect">
             <a:avLst/>
@@ -4508,7 +4309,7 @@
         </p:nvSpPr>
         <p:spPr>
           <a:xfrm>
-            <a:off x="777240" y="6263640"/>
+            <a:off x="777240" y="6217920"/>
             <a:ext cx="10607040" cy="365760"/>
           </a:xfrm>
           <a:prstGeom prst="rect">
@@ -4524,17 +4325,17 @@
           <a:p>
             <a:pPr algn="l">
               <a:spcAft>
-                <a:spcPts val="600"/>
+                <a:spcPts val="700"/>
               </a:spcAft>
             </a:pPr>
             <a:r>
-              <a:rPr sz="1500" b="0">
+              <a:rPr sz="1600" b="0">
                 <a:solidFill>
                   <a:srgbClr val="6E7D76"/>
                 </a:solidFill>
                 <a:latin typeface="Helvetica Neue"/>
               </a:rPr>
-              <a:t>Uzuq chiziqdan tashqariga na ovoz, na matn chiqadi.</a:t>
+              <a:t>Ovoz ham, matn ham shu kompyuterdan chiqmaydi.</a:t>
             </a:r>
           </a:p>
         </p:txBody>
@@ -4609,7 +4410,7 @@
         </p:nvSpPr>
         <p:spPr>
           <a:xfrm>
-            <a:off x="777240" y="548640"/>
+            <a:off x="777240" y="566928"/>
             <a:ext cx="10607040" cy="822960"/>
           </a:xfrm>
           <a:prstGeom prst="rect">
@@ -4625,17 +4426,17 @@
           <a:p>
             <a:pPr algn="l">
               <a:spcAft>
-                <a:spcPts val="600"/>
+                <a:spcPts val="700"/>
               </a:spcAft>
             </a:pPr>
             <a:r>
-              <a:rPr sz="3400" b="1">
+              <a:rPr sz="3300" b="1">
                 <a:solidFill>
                   <a:srgbClr val="131E19"/>
                 </a:solidFill>
                 <a:latin typeface="Helvetica Neue"/>
               </a:rPr>
-              <a:t>Sakkiz qatlam</a:t>
+              <a:t>Eng qiyin masala: dori nomlari</a:t>
             </a:r>
           </a:p>
         </p:txBody>
@@ -4648,7 +4449,7 @@
         </p:nvSpPr>
         <p:spPr>
           <a:xfrm>
-            <a:off x="777240" y="1298448"/>
+            <a:off x="777240" y="1316736"/>
             <a:ext cx="10607040" cy="548640"/>
           </a:xfrm>
           <a:prstGeom prst="rect">
@@ -4664,7 +4465,7 @@
           <a:p>
             <a:pPr algn="l">
               <a:spcAft>
-                <a:spcPts val="600"/>
+                <a:spcPts val="700"/>
               </a:spcAft>
             </a:pPr>
             <a:r>
@@ -4674,14 +4475,14 @@
                 </a:solidFill>
                 <a:latin typeface="Helvetica Neue"/>
               </a:rPr>
-              <a:t>Ikkitasi neyron tarmoq, qolgani oddiy algoritm</a:t>
+              <a:t>Modelni qayta o'qitish oylab vaqt olardi. Dekoderni sozlab hal qildim.</a:t>
             </a:r>
           </a:p>
         </p:txBody>
       </p:sp>
       <p:pic>
         <p:nvPicPr>
-          <p:cNvPr id="5" name="Picture 4" descr="2-qatlamlar.png"/>
+          <p:cNvPr id="5" name="Picture 4" descr="5-dori-tuzatish.png"/>
           <p:cNvPicPr>
             <a:picLocks noChangeAspect="1"/>
           </p:cNvPicPr>
@@ -4695,8 +4496,8 @@
         </p:blipFill>
         <p:spPr>
           <a:xfrm>
-            <a:off x="2203352" y="1965960"/>
-            <a:ext cx="7754815" cy="4480560"/>
+            <a:off x="2053508" y="2011680"/>
+            <a:ext cx="8054502" cy="4206240"/>
           </a:xfrm>
           <a:prstGeom prst="rect">
             <a:avLst/>
@@ -4773,7 +4574,7 @@
         </p:nvSpPr>
         <p:spPr>
           <a:xfrm>
-            <a:off x="777240" y="548640"/>
+            <a:off x="777240" y="566928"/>
             <a:ext cx="10607040" cy="822960"/>
           </a:xfrm>
           <a:prstGeom prst="rect">
@@ -4789,31 +4590,121 @@
           <a:p>
             <a:pPr algn="l">
               <a:spcAft>
-                <a:spcPts val="600"/>
+                <a:spcPts val="700"/>
               </a:spcAft>
             </a:pPr>
             <a:r>
-              <a:rPr sz="3400" b="1">
+              <a:rPr sz="3300" b="1">
                 <a:solidFill>
                   <a:srgbClr val="131E19"/>
                 </a:solidFill>
                 <a:latin typeface="Helvetica Neue"/>
               </a:rPr>
-              <a:t>Eng qiyin masala: dori nomlari</a:t>
-            </a:r>
-          </a:p>
-        </p:txBody>
-      </p:sp>
-      <p:sp>
-        <p:nvSpPr>
-          <p:cNvPr id="4" name="TextBox 3"/>
+              <a:t>Nega shunday qurdim</a:t>
+            </a:r>
+          </a:p>
+        </p:txBody>
+      </p:sp>
+      <p:sp>
+        <p:nvSpPr>
+          <p:cNvPr id="4" name="Rounded Rectangle 3"/>
+          <p:cNvSpPr/>
+          <p:nvPr/>
+        </p:nvSpPr>
+        <p:spPr>
+          <a:xfrm>
+            <a:off x="777240" y="2148840"/>
+            <a:ext cx="10607040" cy="1143000"/>
+          </a:xfrm>
+          <a:prstGeom prst="roundRect">
+            <a:avLst/>
+          </a:prstGeom>
+          <a:solidFill>
+            <a:srgbClr val="FFFFFF"/>
+          </a:solidFill>
+          <a:ln w="9525">
+            <a:solidFill>
+              <a:srgbClr val="D9E0DA"/>
+            </a:solidFill>
+          </a:ln>
+          <a:effectLst/>
+        </p:spPr>
+        <p:style>
+          <a:lnRef idx="1">
+            <a:schemeClr val="accent1"/>
+          </a:lnRef>
+          <a:fillRef idx="3">
+            <a:schemeClr val="accent1"/>
+          </a:fillRef>
+          <a:effectRef idx="2">
+            <a:schemeClr val="accent1"/>
+          </a:effectRef>
+          <a:fontRef idx="minor">
+            <a:schemeClr val="lt1"/>
+          </a:fontRef>
+        </p:style>
+        <p:txBody>
+          <a:bodyPr rtlCol="0" anchor="ctr"/>
+          <a:lstStyle/>
+          <a:p>
+            <a:pPr algn="ctr"/>
+          </a:p>
+        </p:txBody>
+      </p:sp>
+      <p:sp>
+        <p:nvSpPr>
+          <p:cNvPr id="5" name="Rounded Rectangle 4"/>
+          <p:cNvSpPr/>
+          <p:nvPr/>
+        </p:nvSpPr>
+        <p:spPr>
+          <a:xfrm>
+            <a:off x="777240" y="2148840"/>
+            <a:ext cx="64008" cy="1143000"/>
+          </a:xfrm>
+          <a:prstGeom prst="roundRect">
+            <a:avLst/>
+          </a:prstGeom>
+          <a:solidFill>
+            <a:srgbClr val="0E6B58"/>
+          </a:solidFill>
+          <a:ln>
+            <a:noFill/>
+          </a:ln>
+          <a:effectLst/>
+        </p:spPr>
+        <p:style>
+          <a:lnRef idx="1">
+            <a:schemeClr val="accent1"/>
+          </a:lnRef>
+          <a:fillRef idx="3">
+            <a:schemeClr val="accent1"/>
+          </a:fillRef>
+          <a:effectRef idx="2">
+            <a:schemeClr val="accent1"/>
+          </a:effectRef>
+          <a:fontRef idx="minor">
+            <a:schemeClr val="lt1"/>
+          </a:fontRef>
+        </p:style>
+        <p:txBody>
+          <a:bodyPr rtlCol="0" anchor="ctr"/>
+          <a:lstStyle/>
+          <a:p>
+            <a:pPr algn="ctr"/>
+          </a:p>
+        </p:txBody>
+      </p:sp>
+      <p:sp>
+        <p:nvSpPr>
+          <p:cNvPr id="6" name="TextBox 5"/>
           <p:cNvSpPr txBox="1"/>
           <p:nvPr/>
         </p:nvSpPr>
         <p:spPr>
           <a:xfrm>
-            <a:off x="777240" y="1298448"/>
-            <a:ext cx="10607040" cy="548640"/>
+            <a:off x="1115568" y="2313432"/>
+            <a:ext cx="10058400" cy="365760"/>
           </a:xfrm>
           <a:prstGeom prst="rect">
             <a:avLst/>
@@ -4828,45 +4719,435 @@
           <a:p>
             <a:pPr algn="l">
               <a:spcAft>
-                <a:spcPts val="600"/>
+                <a:spcPts val="700"/>
               </a:spcAft>
             </a:pPr>
             <a:r>
-              <a:rPr sz="1600" b="0">
+              <a:rPr sz="2000" b="1">
+                <a:solidFill>
+                  <a:srgbClr val="131E19"/>
+                </a:solidFill>
+                <a:latin typeface="Helvetica Neue"/>
+              </a:rPr>
+              <a:t>Bulut o'rniga lokal</a:t>
+            </a:r>
+          </a:p>
+        </p:txBody>
+      </p:sp>
+      <p:sp>
+        <p:nvSpPr>
+          <p:cNvPr id="7" name="TextBox 6"/>
+          <p:cNvSpPr txBox="1"/>
+          <p:nvPr/>
+        </p:nvSpPr>
+        <p:spPr>
+          <a:xfrm>
+            <a:off x="1115568" y="2752344"/>
+            <a:ext cx="10058400" cy="457200"/>
+          </a:xfrm>
+          <a:prstGeom prst="rect">
+            <a:avLst/>
+          </a:prstGeom>
+          <a:noFill/>
+        </p:spPr>
+        <p:txBody>
+          <a:bodyPr wrap="square" lIns="0" rIns="0" tIns="0" bIns="0">
+            <a:spAutoFit/>
+          </a:bodyPr>
+          <a:lstStyle/>
+          <a:p>
+            <a:pPr algn="l">
+              <a:spcAft>
+                <a:spcPts val="700"/>
+              </a:spcAft>
+            </a:pPr>
+            <a:r>
+              <a:rPr sz="1500" b="0">
                 <a:solidFill>
                   <a:srgbClr val="6E7D76"/>
                 </a:solidFill>
                 <a:latin typeface="Helvetica Neue"/>
               </a:rPr>
-              <a:t>Modelni qayta o'qitish oylab vaqt olardi. Dekoderni sozlash bilan hal qildim.</a:t>
-            </a:r>
-          </a:p>
-        </p:txBody>
-      </p:sp>
-      <p:pic>
-        <p:nvPicPr>
-          <p:cNvPr id="5" name="Picture 4" descr="5-dori-tuzatish.png"/>
-          <p:cNvPicPr>
-            <a:picLocks noChangeAspect="1"/>
-          </p:cNvPicPr>
-          <p:nvPr/>
-        </p:nvPicPr>
-        <p:blipFill>
-          <a:blip r:embed="rId2"/>
-          <a:stretch>
-            <a:fillRect/>
-          </a:stretch>
-        </p:blipFill>
-        <p:spPr>
-          <a:xfrm>
-            <a:off x="2053508" y="2011680"/>
-            <a:ext cx="8054502" cy="4206240"/>
+              <a:t>Bulutli xizmatlar biroz aniqroq tanirdi, lekin bemor ovozi tashqariga chiqardi.</a:t>
+            </a:r>
+          </a:p>
+        </p:txBody>
+      </p:sp>
+      <p:sp>
+        <p:nvSpPr>
+          <p:cNvPr id="8" name="Rounded Rectangle 7"/>
+          <p:cNvSpPr/>
+          <p:nvPr/>
+        </p:nvSpPr>
+        <p:spPr>
+          <a:xfrm>
+            <a:off x="777240" y="3520440"/>
+            <a:ext cx="10607040" cy="1143000"/>
+          </a:xfrm>
+          <a:prstGeom prst="roundRect">
+            <a:avLst/>
+          </a:prstGeom>
+          <a:solidFill>
+            <a:srgbClr val="FFFFFF"/>
+          </a:solidFill>
+          <a:ln w="9525">
+            <a:solidFill>
+              <a:srgbClr val="D9E0DA"/>
+            </a:solidFill>
+          </a:ln>
+          <a:effectLst/>
+        </p:spPr>
+        <p:style>
+          <a:lnRef idx="1">
+            <a:schemeClr val="accent1"/>
+          </a:lnRef>
+          <a:fillRef idx="3">
+            <a:schemeClr val="accent1"/>
+          </a:fillRef>
+          <a:effectRef idx="2">
+            <a:schemeClr val="accent1"/>
+          </a:effectRef>
+          <a:fontRef idx="minor">
+            <a:schemeClr val="lt1"/>
+          </a:fontRef>
+        </p:style>
+        <p:txBody>
+          <a:bodyPr rtlCol="0" anchor="ctr"/>
+          <a:lstStyle/>
+          <a:p>
+            <a:pPr algn="ctr"/>
+          </a:p>
+        </p:txBody>
+      </p:sp>
+      <p:sp>
+        <p:nvSpPr>
+          <p:cNvPr id="9" name="Rounded Rectangle 8"/>
+          <p:cNvSpPr/>
+          <p:nvPr/>
+        </p:nvSpPr>
+        <p:spPr>
+          <a:xfrm>
+            <a:off x="777240" y="3520440"/>
+            <a:ext cx="64008" cy="1143000"/>
+          </a:xfrm>
+          <a:prstGeom prst="roundRect">
+            <a:avLst/>
+          </a:prstGeom>
+          <a:solidFill>
+            <a:srgbClr val="0E6B58"/>
+          </a:solidFill>
+          <a:ln>
+            <a:noFill/>
+          </a:ln>
+          <a:effectLst/>
+        </p:spPr>
+        <p:style>
+          <a:lnRef idx="1">
+            <a:schemeClr val="accent1"/>
+          </a:lnRef>
+          <a:fillRef idx="3">
+            <a:schemeClr val="accent1"/>
+          </a:fillRef>
+          <a:effectRef idx="2">
+            <a:schemeClr val="accent1"/>
+          </a:effectRef>
+          <a:fontRef idx="minor">
+            <a:schemeClr val="lt1"/>
+          </a:fontRef>
+        </p:style>
+        <p:txBody>
+          <a:bodyPr rtlCol="0" anchor="ctr"/>
+          <a:lstStyle/>
+          <a:p>
+            <a:pPr algn="ctr"/>
+          </a:p>
+        </p:txBody>
+      </p:sp>
+      <p:sp>
+        <p:nvSpPr>
+          <p:cNvPr id="10" name="TextBox 9"/>
+          <p:cNvSpPr txBox="1"/>
+          <p:nvPr/>
+        </p:nvSpPr>
+        <p:spPr>
+          <a:xfrm>
+            <a:off x="1115568" y="3685032"/>
+            <a:ext cx="10058400" cy="365760"/>
           </a:xfrm>
           <a:prstGeom prst="rect">
             <a:avLst/>
           </a:prstGeom>
-        </p:spPr>
-      </p:pic>
+          <a:noFill/>
+        </p:spPr>
+        <p:txBody>
+          <a:bodyPr wrap="square" lIns="0" rIns="0" tIns="0" bIns="0">
+            <a:spAutoFit/>
+          </a:bodyPr>
+          <a:lstStyle/>
+          <a:p>
+            <a:pPr algn="l">
+              <a:spcAft>
+                <a:spcPts val="700"/>
+              </a:spcAft>
+            </a:pPr>
+            <a:r>
+              <a:rPr sz="2000" b="1">
+                <a:solidFill>
+                  <a:srgbClr val="131E19"/>
+                </a:solidFill>
+                <a:latin typeface="Helvetica Neue"/>
+              </a:rPr>
+              <a:t>Qayta o'qitish o'rniga sozlash</a:t>
+            </a:r>
+          </a:p>
+        </p:txBody>
+      </p:sp>
+      <p:sp>
+        <p:nvSpPr>
+          <p:cNvPr id="11" name="TextBox 10"/>
+          <p:cNvSpPr txBox="1"/>
+          <p:nvPr/>
+        </p:nvSpPr>
+        <p:spPr>
+          <a:xfrm>
+            <a:off x="1115568" y="4123944"/>
+            <a:ext cx="10058400" cy="457200"/>
+          </a:xfrm>
+          <a:prstGeom prst="rect">
+            <a:avLst/>
+          </a:prstGeom>
+          <a:noFill/>
+        </p:spPr>
+        <p:txBody>
+          <a:bodyPr wrap="square" lIns="0" rIns="0" tIns="0" bIns="0">
+            <a:spAutoFit/>
+          </a:bodyPr>
+          <a:lstStyle/>
+          <a:p>
+            <a:pPr algn="l">
+              <a:spcAft>
+                <a:spcPts val="700"/>
+              </a:spcAft>
+            </a:pPr>
+            <a:r>
+              <a:rPr sz="1500" b="0">
+                <a:solidFill>
+                  <a:srgbClr val="6E7D76"/>
+                </a:solidFill>
+                <a:latin typeface="Helvetica Neue"/>
+              </a:rPr>
+              <a:t>O'qitish oylab vaqt va katta ma'lumot talab qilardi. Sozlash bilan 62 dan 88 foizga chiqdim.</a:t>
+            </a:r>
+          </a:p>
+        </p:txBody>
+      </p:sp>
+      <p:sp>
+        <p:nvSpPr>
+          <p:cNvPr id="12" name="Rounded Rectangle 11"/>
+          <p:cNvSpPr/>
+          <p:nvPr/>
+        </p:nvSpPr>
+        <p:spPr>
+          <a:xfrm>
+            <a:off x="777240" y="4892040"/>
+            <a:ext cx="10607040" cy="1143000"/>
+          </a:xfrm>
+          <a:prstGeom prst="roundRect">
+            <a:avLst/>
+          </a:prstGeom>
+          <a:solidFill>
+            <a:srgbClr val="FFFFFF"/>
+          </a:solidFill>
+          <a:ln w="9525">
+            <a:solidFill>
+              <a:srgbClr val="D9E0DA"/>
+            </a:solidFill>
+          </a:ln>
+          <a:effectLst/>
+        </p:spPr>
+        <p:style>
+          <a:lnRef idx="1">
+            <a:schemeClr val="accent1"/>
+          </a:lnRef>
+          <a:fillRef idx="3">
+            <a:schemeClr val="accent1"/>
+          </a:fillRef>
+          <a:effectRef idx="2">
+            <a:schemeClr val="accent1"/>
+          </a:effectRef>
+          <a:fontRef idx="minor">
+            <a:schemeClr val="lt1"/>
+          </a:fontRef>
+        </p:style>
+        <p:txBody>
+          <a:bodyPr rtlCol="0" anchor="ctr"/>
+          <a:lstStyle/>
+          <a:p>
+            <a:pPr algn="ctr"/>
+          </a:p>
+        </p:txBody>
+      </p:sp>
+      <p:sp>
+        <p:nvSpPr>
+          <p:cNvPr id="13" name="Rounded Rectangle 12"/>
+          <p:cNvSpPr/>
+          <p:nvPr/>
+        </p:nvSpPr>
+        <p:spPr>
+          <a:xfrm>
+            <a:off x="777240" y="4892040"/>
+            <a:ext cx="64008" cy="1143000"/>
+          </a:xfrm>
+          <a:prstGeom prst="roundRect">
+            <a:avLst/>
+          </a:prstGeom>
+          <a:solidFill>
+            <a:srgbClr val="0E6B58"/>
+          </a:solidFill>
+          <a:ln>
+            <a:noFill/>
+          </a:ln>
+          <a:effectLst/>
+        </p:spPr>
+        <p:style>
+          <a:lnRef idx="1">
+            <a:schemeClr val="accent1"/>
+          </a:lnRef>
+          <a:fillRef idx="3">
+            <a:schemeClr val="accent1"/>
+          </a:fillRef>
+          <a:effectRef idx="2">
+            <a:schemeClr val="accent1"/>
+          </a:effectRef>
+          <a:fontRef idx="minor">
+            <a:schemeClr val="lt1"/>
+          </a:fontRef>
+        </p:style>
+        <p:txBody>
+          <a:bodyPr rtlCol="0" anchor="ctr"/>
+          <a:lstStyle/>
+          <a:p>
+            <a:pPr algn="ctr"/>
+          </a:p>
+        </p:txBody>
+      </p:sp>
+      <p:sp>
+        <p:nvSpPr>
+          <p:cNvPr id="14" name="TextBox 13"/>
+          <p:cNvSpPr txBox="1"/>
+          <p:nvPr/>
+        </p:nvSpPr>
+        <p:spPr>
+          <a:xfrm>
+            <a:off x="1115568" y="5056631"/>
+            <a:ext cx="10058400" cy="365760"/>
+          </a:xfrm>
+          <a:prstGeom prst="rect">
+            <a:avLst/>
+          </a:prstGeom>
+          <a:noFill/>
+        </p:spPr>
+        <p:txBody>
+          <a:bodyPr wrap="square" lIns="0" rIns="0" tIns="0" bIns="0">
+            <a:spAutoFit/>
+          </a:bodyPr>
+          <a:lstStyle/>
+          <a:p>
+            <a:pPr algn="l">
+              <a:spcAft>
+                <a:spcPts val="700"/>
+              </a:spcAft>
+            </a:pPr>
+            <a:r>
+              <a:rPr sz="2000" b="1">
+                <a:solidFill>
+                  <a:srgbClr val="131E19"/>
+                </a:solidFill>
+                <a:latin typeface="Helvetica Neue"/>
+              </a:rPr>
+              <a:t>Til modeli o'rniga oddiy usul</a:t>
+            </a:r>
+          </a:p>
+        </p:txBody>
+      </p:sp>
+      <p:sp>
+        <p:nvSpPr>
+          <p:cNvPr id="15" name="TextBox 14"/>
+          <p:cNvSpPr txBox="1"/>
+          <p:nvPr/>
+        </p:nvSpPr>
+        <p:spPr>
+          <a:xfrm>
+            <a:off x="1115568" y="5495544"/>
+            <a:ext cx="10058400" cy="457200"/>
+          </a:xfrm>
+          <a:prstGeom prst="rect">
+            <a:avLst/>
+          </a:prstGeom>
+          <a:noFill/>
+        </p:spPr>
+        <p:txBody>
+          <a:bodyPr wrap="square" lIns="0" rIns="0" tIns="0" bIns="0">
+            <a:spAutoFit/>
+          </a:bodyPr>
+          <a:lstStyle/>
+          <a:p>
+            <a:pPr algn="l">
+              <a:spcAft>
+                <a:spcPts val="700"/>
+              </a:spcAft>
+            </a:pPr>
+            <a:r>
+              <a:rPr sz="1500" b="0">
+                <a:solidFill>
+                  <a:srgbClr val="6E7D76"/>
+                </a:solidFill>
+                <a:latin typeface="Helvetica Neue"/>
+              </a:rPr>
+              <a:t>Tashxis kodiga til modeli qo'yish mumkin edi. Oddiy usul tezroq ishladi va qaysi so'z sabab bo'lganini ko'rsatadi.</a:t>
+            </a:r>
+          </a:p>
+        </p:txBody>
+      </p:sp>
+      <p:sp>
+        <p:nvSpPr>
+          <p:cNvPr id="16" name="TextBox 15"/>
+          <p:cNvSpPr txBox="1"/>
+          <p:nvPr/>
+        </p:nvSpPr>
+        <p:spPr>
+          <a:xfrm>
+            <a:off x="777240" y="6355080"/>
+            <a:ext cx="10607040" cy="365760"/>
+          </a:xfrm>
+          <a:prstGeom prst="rect">
+            <a:avLst/>
+          </a:prstGeom>
+          <a:noFill/>
+        </p:spPr>
+        <p:txBody>
+          <a:bodyPr wrap="square" lIns="0" rIns="0" tIns="0" bIns="0">
+            <a:spAutoFit/>
+          </a:bodyPr>
+          <a:lstStyle/>
+          <a:p>
+            <a:pPr algn="l">
+              <a:spcAft>
+                <a:spcPts val="700"/>
+              </a:spcAft>
+            </a:pPr>
+            <a:r>
+              <a:rPr sz="1500" b="0">
+                <a:solidFill>
+                  <a:srgbClr val="A05007"/>
+                </a:solidFill>
+                <a:latin typeface="Helvetica Neue"/>
+              </a:rPr>
+              <a:t>Har bir tanlovda tezlik va tushuntirib bera olish muhimroq bo'ldi.</a:t>
+            </a:r>
+          </a:p>
+        </p:txBody>
+      </p:sp>
     </p:spTree>
   </p:cSld>
   <p:clrMapOvr>
@@ -4937,7 +5218,7 @@
         </p:nvSpPr>
         <p:spPr>
           <a:xfrm>
-            <a:off x="777240" y="548640"/>
+            <a:off x="777240" y="566928"/>
             <a:ext cx="10607040" cy="822960"/>
           </a:xfrm>
           <a:prstGeom prst="rect">
@@ -4953,345 +5234,17 @@
           <a:p>
             <a:pPr algn="l">
               <a:spcAft>
-                <a:spcPts val="600"/>
+                <a:spcPts val="700"/>
               </a:spcAft>
             </a:pPr>
             <a:r>
-              <a:rPr sz="3400" b="1">
+              <a:rPr sz="3300" b="1">
                 <a:solidFill>
                   <a:srgbClr val="131E19"/>
                 </a:solidFill>
                 <a:latin typeface="Helvetica Neue"/>
               </a:rPr>
-              <a:t>Tizim qachon ishonmasligini biladi</a:t>
-            </a:r>
-          </a:p>
-        </p:txBody>
-      </p:sp>
-      <p:sp>
-        <p:nvSpPr>
-          <p:cNvPr id="4" name="TextBox 3"/>
-          <p:cNvSpPr txBox="1"/>
-          <p:nvPr/>
-        </p:nvSpPr>
-        <p:spPr>
-          <a:xfrm>
-            <a:off x="777240" y="1298448"/>
-            <a:ext cx="10607040" cy="548640"/>
-          </a:xfrm>
-          <a:prstGeom prst="rect">
-            <a:avLst/>
-          </a:prstGeom>
-          <a:noFill/>
-        </p:spPr>
-        <p:txBody>
-          <a:bodyPr wrap="square" lIns="0" rIns="0" tIns="0" bIns="0">
-            <a:spAutoFit/>
-          </a:bodyPr>
-          <a:lstStyle/>
-          <a:p>
-            <a:pPr algn="l">
-              <a:spcAft>
-                <a:spcPts val="600"/>
-              </a:spcAft>
-            </a:pPr>
-            <a:r>
-              <a:rPr sz="1600" b="0">
-                <a:solidFill>
-                  <a:srgbClr val="6E7D76"/>
-                </a:solidFill>
-                <a:latin typeface="Helvetica Neue"/>
-              </a:rPr>
-              <a:t>Uchta mustaqil nazorat. Birortasi ishlasa, shifokor tekshiradi.</a:t>
-            </a:r>
-          </a:p>
-        </p:txBody>
-      </p:sp>
-      <p:pic>
-        <p:nvPicPr>
-          <p:cNvPr id="5" name="Picture 4" descr="3-gallyutsinatsiya.png"/>
-          <p:cNvPicPr>
-            <a:picLocks noChangeAspect="1"/>
-          </p:cNvPicPr>
-          <p:nvPr/>
-        </p:nvPicPr>
-        <p:blipFill>
-          <a:blip r:embed="rId2"/>
-          <a:stretch>
-            <a:fillRect/>
-          </a:stretch>
-        </p:blipFill>
-        <p:spPr>
-          <a:xfrm>
-            <a:off x="1754451" y="2011680"/>
-            <a:ext cx="8652616" cy="4114800"/>
-          </a:xfrm>
-          <a:prstGeom prst="rect">
-            <a:avLst/>
-          </a:prstGeom>
-        </p:spPr>
-      </p:pic>
-    </p:spTree>
-  </p:cSld>
-  <p:clrMapOvr>
-    <a:masterClrMapping/>
-  </p:clrMapOvr>
-</p:sld>
-</file>
-
-<file path=ppt/slides/slide7.xml><?xml version="1.0" encoding="utf-8"?>
-<p:sld xmlns:a="http://schemas.openxmlformats.org/drawingml/2006/main" xmlns:p="http://schemas.openxmlformats.org/presentationml/2006/main" xmlns:r="http://schemas.openxmlformats.org/officeDocument/2006/relationships">
-  <p:cSld>
-    <p:spTree>
-      <p:nvGrpSpPr>
-        <p:cNvPr id="1" name=""/>
-        <p:cNvGrpSpPr/>
-        <p:nvPr/>
-      </p:nvGrpSpPr>
-      <p:grpSpPr/>
-      <p:sp>
-        <p:nvSpPr>
-          <p:cNvPr id="2" name="Rectangle 1"/>
-          <p:cNvSpPr/>
-          <p:nvPr/>
-        </p:nvSpPr>
-        <p:spPr>
-          <a:xfrm>
-            <a:off x="0" y="0"/>
-            <a:ext cx="12191695" cy="6858000"/>
-          </a:xfrm>
-          <a:prstGeom prst="rect">
-            <a:avLst/>
-          </a:prstGeom>
-          <a:solidFill>
-            <a:srgbClr val="F6F7F4"/>
-          </a:solidFill>
-          <a:ln>
-            <a:noFill/>
-          </a:ln>
-          <a:effectLst/>
-        </p:spPr>
-        <p:style>
-          <a:lnRef idx="1">
-            <a:schemeClr val="accent1"/>
-          </a:lnRef>
-          <a:fillRef idx="3">
-            <a:schemeClr val="accent1"/>
-          </a:fillRef>
-          <a:effectRef idx="2">
-            <a:schemeClr val="accent1"/>
-          </a:effectRef>
-          <a:fontRef idx="minor">
-            <a:schemeClr val="lt1"/>
-          </a:fontRef>
-        </p:style>
-        <p:txBody>
-          <a:bodyPr rtlCol="0" anchor="ctr"/>
-          <a:lstStyle/>
-          <a:p>
-            <a:pPr algn="ctr"/>
-          </a:p>
-        </p:txBody>
-      </p:sp>
-      <p:sp>
-        <p:nvSpPr>
-          <p:cNvPr id="3" name="TextBox 2"/>
-          <p:cNvSpPr txBox="1"/>
-          <p:nvPr/>
-        </p:nvSpPr>
-        <p:spPr>
-          <a:xfrm>
-            <a:off x="777240" y="548640"/>
-            <a:ext cx="10607040" cy="822960"/>
-          </a:xfrm>
-          <a:prstGeom prst="rect">
-            <a:avLst/>
-          </a:prstGeom>
-          <a:noFill/>
-        </p:spPr>
-        <p:txBody>
-          <a:bodyPr wrap="square" lIns="0" rIns="0" tIns="0" bIns="0">
-            <a:spAutoFit/>
-          </a:bodyPr>
-          <a:lstStyle/>
-          <a:p>
-            <a:pPr algn="l">
-              <a:spcAft>
-                <a:spcPts val="600"/>
-              </a:spcAft>
-            </a:pPr>
-            <a:r>
-              <a:rPr sz="3400" b="1">
-                <a:solidFill>
-                  <a:srgbClr val="131E19"/>
-                </a:solidFill>
-                <a:latin typeface="Helvetica Neue"/>
-              </a:rPr>
-              <a:t>“Og'riq yo'q” degani ham ma'lumot</a:t>
-            </a:r>
-          </a:p>
-        </p:txBody>
-      </p:sp>
-      <p:sp>
-        <p:nvSpPr>
-          <p:cNvPr id="4" name="TextBox 3"/>
-          <p:cNvSpPr txBox="1"/>
-          <p:nvPr/>
-        </p:nvSpPr>
-        <p:spPr>
-          <a:xfrm>
-            <a:off x="777240" y="1298448"/>
-            <a:ext cx="10607040" cy="548640"/>
-          </a:xfrm>
-          <a:prstGeom prst="rect">
-            <a:avLst/>
-          </a:prstGeom>
-          <a:noFill/>
-        </p:spPr>
-        <p:txBody>
-          <a:bodyPr wrap="square" lIns="0" rIns="0" tIns="0" bIns="0">
-            <a:spAutoFit/>
-          </a:bodyPr>
-          <a:lstStyle/>
-          <a:p>
-            <a:pPr algn="l">
-              <a:spcAft>
-                <a:spcPts val="600"/>
-              </a:spcAft>
-            </a:pPr>
-            <a:r>
-              <a:rPr sz="1600" b="0">
-                <a:solidFill>
-                  <a:srgbClr val="6E7D76"/>
-                </a:solidFill>
-                <a:latin typeface="Helvetica Neue"/>
-              </a:rPr>
-              <a:t>Inkorni tushunmagan tizim bemorga yo'q kasallik kodini yozadi</a:t>
-            </a:r>
-          </a:p>
-        </p:txBody>
-      </p:sp>
-      <p:pic>
-        <p:nvPicPr>
-          <p:cNvPr id="5" name="Picture 4" descr="4-inkor-kodlash.png"/>
-          <p:cNvPicPr>
-            <a:picLocks noChangeAspect="1"/>
-          </p:cNvPicPr>
-          <p:nvPr/>
-        </p:nvPicPr>
-        <p:blipFill>
-          <a:blip r:embed="rId2"/>
-          <a:stretch>
-            <a:fillRect/>
-          </a:stretch>
-        </p:blipFill>
-        <p:spPr>
-          <a:xfrm>
-            <a:off x="1672045" y="2011680"/>
-            <a:ext cx="8817428" cy="4114800"/>
-          </a:xfrm>
-          <a:prstGeom prst="rect">
-            <a:avLst/>
-          </a:prstGeom>
-        </p:spPr>
-      </p:pic>
-    </p:spTree>
-  </p:cSld>
-  <p:clrMapOvr>
-    <a:masterClrMapping/>
-  </p:clrMapOvr>
-</p:sld>
-</file>
-
-<file path=ppt/slides/slide8.xml><?xml version="1.0" encoding="utf-8"?>
-<p:sld xmlns:a="http://schemas.openxmlformats.org/drawingml/2006/main" xmlns:p="http://schemas.openxmlformats.org/presentationml/2006/main" xmlns:r="http://schemas.openxmlformats.org/officeDocument/2006/relationships">
-  <p:cSld>
-    <p:spTree>
-      <p:nvGrpSpPr>
-        <p:cNvPr id="1" name=""/>
-        <p:cNvGrpSpPr/>
-        <p:nvPr/>
-      </p:nvGrpSpPr>
-      <p:grpSpPr/>
-      <p:sp>
-        <p:nvSpPr>
-          <p:cNvPr id="2" name="Rectangle 1"/>
-          <p:cNvSpPr/>
-          <p:nvPr/>
-        </p:nvSpPr>
-        <p:spPr>
-          <a:xfrm>
-            <a:off x="0" y="0"/>
-            <a:ext cx="12191695" cy="6858000"/>
-          </a:xfrm>
-          <a:prstGeom prst="rect">
-            <a:avLst/>
-          </a:prstGeom>
-          <a:solidFill>
-            <a:srgbClr val="F6F7F4"/>
-          </a:solidFill>
-          <a:ln>
-            <a:noFill/>
-          </a:ln>
-          <a:effectLst/>
-        </p:spPr>
-        <p:style>
-          <a:lnRef idx="1">
-            <a:schemeClr val="accent1"/>
-          </a:lnRef>
-          <a:fillRef idx="3">
-            <a:schemeClr val="accent1"/>
-          </a:fillRef>
-          <a:effectRef idx="2">
-            <a:schemeClr val="accent1"/>
-          </a:effectRef>
-          <a:fontRef idx="minor">
-            <a:schemeClr val="lt1"/>
-          </a:fontRef>
-        </p:style>
-        <p:txBody>
-          <a:bodyPr rtlCol="0" anchor="ctr"/>
-          <a:lstStyle/>
-          <a:p>
-            <a:pPr algn="ctr"/>
-          </a:p>
-        </p:txBody>
-      </p:sp>
-      <p:sp>
-        <p:nvSpPr>
-          <p:cNvPr id="3" name="TextBox 2"/>
-          <p:cNvSpPr txBox="1"/>
-          <p:nvPr/>
-        </p:nvSpPr>
-        <p:spPr>
-          <a:xfrm>
-            <a:off x="777240" y="548640"/>
-            <a:ext cx="10607040" cy="822960"/>
-          </a:xfrm>
-          <a:prstGeom prst="rect">
-            <a:avLst/>
-          </a:prstGeom>
-          <a:noFill/>
-        </p:spPr>
-        <p:txBody>
-          <a:bodyPr wrap="square" lIns="0" rIns="0" tIns="0" bIns="0">
-            <a:spAutoFit/>
-          </a:bodyPr>
-          <a:lstStyle/>
-          <a:p>
-            <a:pPr algn="l">
-              <a:spcAft>
-                <a:spcPts val="600"/>
-              </a:spcAft>
-            </a:pPr>
-            <a:r>
-              <a:rPr sz="3400" b="1">
-                <a:solidFill>
-                  <a:srgbClr val="131E19"/>
-                </a:solidFill>
-                <a:latin typeface="Helvetica Neue"/>
-              </a:rPr>
-              <a:t>Nega shunday qurdim</a:t>
+              <a:t>Ishonchlilik</a:t>
             </a:r>
           </a:p>
         </p:txBody>
@@ -5304,8 +5257,8 @@
         </p:nvSpPr>
         <p:spPr>
           <a:xfrm>
-            <a:off x="777240" y="2103120"/>
-            <a:ext cx="10607040" cy="1097280"/>
+            <a:off x="777240" y="2286000"/>
+            <a:ext cx="3383280" cy="2194560"/>
           </a:xfrm>
           <a:prstGeom prst="roundRect">
             <a:avLst/>
@@ -5350,8 +5303,8 @@
         </p:nvSpPr>
         <p:spPr>
           <a:xfrm>
-            <a:off x="777240" y="2103120"/>
-            <a:ext cx="64008" cy="1097280"/>
+            <a:off x="777240" y="2286000"/>
+            <a:ext cx="64008" cy="2194560"/>
           </a:xfrm>
           <a:prstGeom prst="roundRect">
             <a:avLst/>
@@ -5394,8 +5347,8 @@
         </p:nvSpPr>
         <p:spPr>
           <a:xfrm>
-            <a:off x="1097280" y="2249424"/>
-            <a:ext cx="10058400" cy="365760"/>
+            <a:off x="1161288" y="2633472"/>
+            <a:ext cx="2743200" cy="731520"/>
           </a:xfrm>
           <a:prstGeom prst="rect">
             <a:avLst/>
@@ -5410,31 +5363,70 @@
           <a:p>
             <a:pPr algn="l">
               <a:spcAft>
-                <a:spcPts val="600"/>
+                <a:spcPts val="700"/>
               </a:spcAft>
             </a:pPr>
             <a:r>
-              <a:rPr sz="1900" b="1">
+              <a:rPr sz="3800" b="1">
+                <a:solidFill>
+                  <a:srgbClr val="0E6B58"/>
+                </a:solidFill>
+                <a:latin typeface="Helvetica Neue"/>
+              </a:rPr>
+              <a:t>51</a:t>
+            </a:r>
+          </a:p>
+        </p:txBody>
+      </p:sp>
+      <p:sp>
+        <p:nvSpPr>
+          <p:cNvPr id="7" name="TextBox 6"/>
+          <p:cNvSpPr txBox="1"/>
+          <p:nvPr/>
+        </p:nvSpPr>
+        <p:spPr>
+          <a:xfrm>
+            <a:off x="1161288" y="3364992"/>
+            <a:ext cx="2743200" cy="365760"/>
+          </a:xfrm>
+          <a:prstGeom prst="rect">
+            <a:avLst/>
+          </a:prstGeom>
+          <a:noFill/>
+        </p:spPr>
+        <p:txBody>
+          <a:bodyPr wrap="square" lIns="0" rIns="0" tIns="0" bIns="0">
+            <a:spAutoFit/>
+          </a:bodyPr>
+          <a:lstStyle/>
+          <a:p>
+            <a:pPr algn="l">
+              <a:spcAft>
+                <a:spcPts val="700"/>
+              </a:spcAft>
+            </a:pPr>
+            <a:r>
+              <a:rPr sz="1700" b="1">
                 <a:solidFill>
                   <a:srgbClr val="131E19"/>
                 </a:solidFill>
                 <a:latin typeface="Helvetica Neue"/>
               </a:rPr>
-              <a:t>Bulut o'rniga lokal</a:t>
-            </a:r>
-          </a:p>
-        </p:txBody>
-      </p:sp>
-      <p:sp>
-        <p:nvSpPr>
-          <p:cNvPr id="7" name="TextBox 6"/>
+              <a:t>avtomatik test</a:t>
+            </a:r>
+          </a:p>
+        </p:txBody>
+      </p:sp>
+      <p:sp>
+        <p:nvSpPr>
+          <p:cNvPr id="8" name="TextBox 7"/>
           <p:cNvSpPr txBox="1"/>
           <p:nvPr/>
         </p:nvSpPr>
         <p:spPr>
           <a:xfrm>
-            <a:off x="1097280" y="2670048"/>
-            <a:ext cx="10058400" cy="457200"/>
+            <a:off x="1161288" y="3767328"/>
+            <a:ext cx="2743200" cy="640080"/>
           </a:xfrm>
           <a:prstGeom prst="rect">
             <a:avLst/>
@@ -5449,31 +5441,31 @@
           <a:p>
             <a:pPr algn="l">
               <a:spcAft>
-                <a:spcPts val="600"/>
+                <a:spcPts val="700"/>
               </a:spcAft>
             </a:pPr>
             <a:r>
-              <a:rPr sz="1500" b="0">
+              <a:rPr sz="1300" b="0">
                 <a:solidFill>
                   <a:srgbClr val="6E7D76"/>
                 </a:solidFill>
                 <a:latin typeface="Helvetica Neue"/>
               </a:rPr>
-              <a:t>Bulutli xizmatlar biroz aniqroq tanirdi, lekin bemor ovozi tashqariga chiqardi.</a:t>
-            </a:r>
-          </a:p>
-        </p:txBody>
-      </p:sp>
-      <p:sp>
-        <p:nvSpPr>
-          <p:cNvPr id="8" name="Rounded Rectangle 7"/>
+              <a:t>Bir marta tuzatilgan xato qaytib kelmaydi</a:t>
+            </a:r>
+          </a:p>
+        </p:txBody>
+      </p:sp>
+      <p:sp>
+        <p:nvSpPr>
+          <p:cNvPr id="9" name="Rounded Rectangle 8"/>
           <p:cNvSpPr/>
           <p:nvPr/>
         </p:nvSpPr>
         <p:spPr>
           <a:xfrm>
-            <a:off x="777240" y="3429000"/>
-            <a:ext cx="10607040" cy="1097280"/>
+            <a:off x="4389120" y="2286000"/>
+            <a:ext cx="3383280" cy="2194560"/>
           </a:xfrm>
           <a:prstGeom prst="roundRect">
             <a:avLst/>
@@ -5512,14 +5504,14 @@
       </p:sp>
       <p:sp>
         <p:nvSpPr>
-          <p:cNvPr id="9" name="Rounded Rectangle 8"/>
+          <p:cNvPr id="10" name="Rounded Rectangle 9"/>
           <p:cNvSpPr/>
           <p:nvPr/>
         </p:nvSpPr>
         <p:spPr>
           <a:xfrm>
-            <a:off x="777240" y="3429000"/>
-            <a:ext cx="64008" cy="1097280"/>
+            <a:off x="4389120" y="2286000"/>
+            <a:ext cx="64008" cy="2194560"/>
           </a:xfrm>
           <a:prstGeom prst="roundRect">
             <a:avLst/>
@@ -5556,14 +5548,14 @@
       </p:sp>
       <p:sp>
         <p:nvSpPr>
-          <p:cNvPr id="10" name="TextBox 9"/>
+          <p:cNvPr id="11" name="TextBox 10"/>
           <p:cNvSpPr txBox="1"/>
           <p:nvPr/>
         </p:nvSpPr>
         <p:spPr>
           <a:xfrm>
-            <a:off x="1097280" y="3575304"/>
-            <a:ext cx="10058400" cy="365760"/>
+            <a:off x="4773168" y="2633472"/>
+            <a:ext cx="2743200" cy="731520"/>
           </a:xfrm>
           <a:prstGeom prst="rect">
             <a:avLst/>
@@ -5578,31 +5570,70 @@
           <a:p>
             <a:pPr algn="l">
               <a:spcAft>
-                <a:spcPts val="600"/>
+                <a:spcPts val="700"/>
               </a:spcAft>
             </a:pPr>
             <a:r>
-              <a:rPr sz="1900" b="1">
+              <a:rPr sz="3800" b="1">
+                <a:solidFill>
+                  <a:srgbClr val="0E6B58"/>
+                </a:solidFill>
+                <a:latin typeface="Helvetica Neue"/>
+              </a:rPr>
+              <a:t>100%</a:t>
+            </a:r>
+          </a:p>
+        </p:txBody>
+      </p:sp>
+      <p:sp>
+        <p:nvSpPr>
+          <p:cNvPr id="12" name="TextBox 11"/>
+          <p:cNvSpPr txBox="1"/>
+          <p:nvPr/>
+        </p:nvSpPr>
+        <p:spPr>
+          <a:xfrm>
+            <a:off x="4773168" y="3364992"/>
+            <a:ext cx="2743200" cy="365760"/>
+          </a:xfrm>
+          <a:prstGeom prst="rect">
+            <a:avLst/>
+          </a:prstGeom>
+          <a:noFill/>
+        </p:spPr>
+        <p:txBody>
+          <a:bodyPr wrap="square" lIns="0" rIns="0" tIns="0" bIns="0">
+            <a:spAutoFit/>
+          </a:bodyPr>
+          <a:lstStyle/>
+          <a:p>
+            <a:pPr algn="l">
+              <a:spcAft>
+                <a:spcPts val="700"/>
+              </a:spcAft>
+            </a:pPr>
+            <a:r>
+              <a:rPr sz="1700" b="1">
                 <a:solidFill>
                   <a:srgbClr val="131E19"/>
                 </a:solidFill>
                 <a:latin typeface="Helvetica Neue"/>
               </a:rPr>
-              <a:t>Qayta o'qitish o'rniga dekoder sozlash</a:t>
-            </a:r>
-          </a:p>
-        </p:txBody>
-      </p:sp>
-      <p:sp>
-        <p:nvSpPr>
-          <p:cNvPr id="11" name="TextBox 10"/>
+              <a:t>shifokor nazorati</a:t>
+            </a:r>
+          </a:p>
+        </p:txBody>
+      </p:sp>
+      <p:sp>
+        <p:nvSpPr>
+          <p:cNvPr id="13" name="TextBox 12"/>
           <p:cNvSpPr txBox="1"/>
           <p:nvPr/>
         </p:nvSpPr>
         <p:spPr>
           <a:xfrm>
-            <a:off x="1097280" y="3995928"/>
-            <a:ext cx="10058400" cy="457200"/>
+            <a:off x="4773168" y="3767328"/>
+            <a:ext cx="2743200" cy="640080"/>
           </a:xfrm>
           <a:prstGeom prst="rect">
             <a:avLst/>
@@ -5617,31 +5648,31 @@
           <a:p>
             <a:pPr algn="l">
               <a:spcAft>
-                <a:spcPts val="600"/>
+                <a:spcPts val="700"/>
               </a:spcAft>
             </a:pPr>
             <a:r>
-              <a:rPr sz="1500" b="0">
+              <a:rPr sz="1300" b="0">
                 <a:solidFill>
                   <a:srgbClr val="6E7D76"/>
                 </a:solidFill>
                 <a:latin typeface="Helvetica Neue"/>
               </a:rPr>
-              <a:t>Model o'qitish oylab vaqt va katta ma'lumot talab qilardi. Sozlash bilan 62 dan 88 foizga chiqdim.</a:t>
-            </a:r>
-          </a:p>
-        </p:txBody>
-      </p:sp>
-      <p:sp>
-        <p:nvSpPr>
-          <p:cNvPr id="12" name="Rounded Rectangle 11"/>
+              <a:t>Past ishonchli taklif o'zi yoqilmaydi</a:t>
+            </a:r>
+          </a:p>
+        </p:txBody>
+      </p:sp>
+      <p:sp>
+        <p:nvSpPr>
+          <p:cNvPr id="14" name="Rounded Rectangle 13"/>
           <p:cNvSpPr/>
           <p:nvPr/>
         </p:nvSpPr>
         <p:spPr>
           <a:xfrm>
-            <a:off x="777240" y="4754879"/>
-            <a:ext cx="10607040" cy="1097280"/>
+            <a:off x="8001000" y="2286000"/>
+            <a:ext cx="3383280" cy="2194560"/>
           </a:xfrm>
           <a:prstGeom prst="roundRect">
             <a:avLst/>
@@ -5680,14 +5711,14 @@
       </p:sp>
       <p:sp>
         <p:nvSpPr>
-          <p:cNvPr id="13" name="Rounded Rectangle 12"/>
+          <p:cNvPr id="15" name="Rounded Rectangle 14"/>
           <p:cNvSpPr/>
           <p:nvPr/>
         </p:nvSpPr>
         <p:spPr>
           <a:xfrm>
-            <a:off x="777240" y="4754879"/>
-            <a:ext cx="64008" cy="1097280"/>
+            <a:off x="8001000" y="2286000"/>
+            <a:ext cx="64008" cy="2194560"/>
           </a:xfrm>
           <a:prstGeom prst="roundRect">
             <a:avLst/>
@@ -5724,14 +5755,14 @@
       </p:sp>
       <p:sp>
         <p:nvSpPr>
-          <p:cNvPr id="14" name="TextBox 13"/>
+          <p:cNvPr id="16" name="TextBox 15"/>
           <p:cNvSpPr txBox="1"/>
           <p:nvPr/>
         </p:nvSpPr>
         <p:spPr>
           <a:xfrm>
-            <a:off x="1097280" y="4901183"/>
-            <a:ext cx="10058400" cy="365760"/>
+            <a:off x="8385048" y="2633472"/>
+            <a:ext cx="2743200" cy="731520"/>
           </a:xfrm>
           <a:prstGeom prst="rect">
             <a:avLst/>
@@ -5746,729 +5777,7 @@
           <a:p>
             <a:pPr algn="l">
               <a:spcAft>
-                <a:spcPts val="600"/>
-              </a:spcAft>
-            </a:pPr>
-            <a:r>
-              <a:rPr sz="1900" b="1">
-                <a:solidFill>
-                  <a:srgbClr val="131E19"/>
-                </a:solidFill>
-                <a:latin typeface="Helvetica Neue"/>
-              </a:rPr>
-              <a:t>Til modeli o'rniga oddiy usul</a:t>
-            </a:r>
-          </a:p>
-        </p:txBody>
-      </p:sp>
-      <p:sp>
-        <p:nvSpPr>
-          <p:cNvPr id="15" name="TextBox 14"/>
-          <p:cNvSpPr txBox="1"/>
-          <p:nvPr/>
-        </p:nvSpPr>
-        <p:spPr>
-          <a:xfrm>
-            <a:off x="1097280" y="5321807"/>
-            <a:ext cx="10058400" cy="457200"/>
-          </a:xfrm>
-          <a:prstGeom prst="rect">
-            <a:avLst/>
-          </a:prstGeom>
-          <a:noFill/>
-        </p:spPr>
-        <p:txBody>
-          <a:bodyPr wrap="square" lIns="0" rIns="0" tIns="0" bIns="0">
-            <a:spAutoFit/>
-          </a:bodyPr>
-          <a:lstStyle/>
-          <a:p>
-            <a:pPr algn="l">
-              <a:spcAft>
-                <a:spcPts val="600"/>
-              </a:spcAft>
-            </a:pPr>
-            <a:r>
-              <a:rPr sz="1500" b="0">
-                <a:solidFill>
-                  <a:srgbClr val="6E7D76"/>
-                </a:solidFill>
-                <a:latin typeface="Helvetica Neue"/>
-              </a:rPr>
-              <a:t>Tashxis kodiga til modeli qo'yish mumkin edi. Oddiy usul tezroq ishladi va qaysi so'z sabab bo'lganini ko'rsatadi.</a:t>
-            </a:r>
-          </a:p>
-        </p:txBody>
-      </p:sp>
-      <p:sp>
-        <p:nvSpPr>
-          <p:cNvPr id="16" name="TextBox 15"/>
-          <p:cNvSpPr txBox="1"/>
-          <p:nvPr/>
-        </p:nvSpPr>
-        <p:spPr>
-          <a:xfrm>
-            <a:off x="777240" y="6172200"/>
-            <a:ext cx="10607040" cy="457200"/>
-          </a:xfrm>
-          <a:prstGeom prst="rect">
-            <a:avLst/>
-          </a:prstGeom>
-          <a:noFill/>
-        </p:spPr>
-        <p:txBody>
-          <a:bodyPr wrap="square" lIns="0" rIns="0" tIns="0" bIns="0">
-            <a:spAutoFit/>
-          </a:bodyPr>
-          <a:lstStyle/>
-          <a:p>
-            <a:pPr algn="l">
-              <a:spcAft>
-                <a:spcPts val="600"/>
-              </a:spcAft>
-            </a:pPr>
-            <a:r>
-              <a:rPr sz="1500" b="0">
-                <a:solidFill>
-                  <a:srgbClr val="A05007"/>
-                </a:solidFill>
-                <a:latin typeface="Helvetica Neue"/>
-              </a:rPr>
-              <a:t>Har bir tanlovda tezlik va tushuntirib bera olish muhimroq bo'ldi.</a:t>
-            </a:r>
-          </a:p>
-        </p:txBody>
-      </p:sp>
-    </p:spTree>
-  </p:cSld>
-  <p:clrMapOvr>
-    <a:masterClrMapping/>
-  </p:clrMapOvr>
-</p:sld>
-</file>
-
-<file path=ppt/slides/slide9.xml><?xml version="1.0" encoding="utf-8"?>
-<p:sld xmlns:a="http://schemas.openxmlformats.org/drawingml/2006/main" xmlns:p="http://schemas.openxmlformats.org/presentationml/2006/main" xmlns:r="http://schemas.openxmlformats.org/officeDocument/2006/relationships">
-  <p:cSld>
-    <p:spTree>
-      <p:nvGrpSpPr>
-        <p:cNvPr id="1" name=""/>
-        <p:cNvGrpSpPr/>
-        <p:nvPr/>
-      </p:nvGrpSpPr>
-      <p:grpSpPr/>
-      <p:sp>
-        <p:nvSpPr>
-          <p:cNvPr id="2" name="Rectangle 1"/>
-          <p:cNvSpPr/>
-          <p:nvPr/>
-        </p:nvSpPr>
-        <p:spPr>
-          <a:xfrm>
-            <a:off x="0" y="0"/>
-            <a:ext cx="12191695" cy="6858000"/>
-          </a:xfrm>
-          <a:prstGeom prst="rect">
-            <a:avLst/>
-          </a:prstGeom>
-          <a:solidFill>
-            <a:srgbClr val="F6F7F4"/>
-          </a:solidFill>
-          <a:ln>
-            <a:noFill/>
-          </a:ln>
-          <a:effectLst/>
-        </p:spPr>
-        <p:style>
-          <a:lnRef idx="1">
-            <a:schemeClr val="accent1"/>
-          </a:lnRef>
-          <a:fillRef idx="3">
-            <a:schemeClr val="accent1"/>
-          </a:fillRef>
-          <a:effectRef idx="2">
-            <a:schemeClr val="accent1"/>
-          </a:effectRef>
-          <a:fontRef idx="minor">
-            <a:schemeClr val="lt1"/>
-          </a:fontRef>
-        </p:style>
-        <p:txBody>
-          <a:bodyPr rtlCol="0" anchor="ctr"/>
-          <a:lstStyle/>
-          <a:p>
-            <a:pPr algn="ctr"/>
-          </a:p>
-        </p:txBody>
-      </p:sp>
-      <p:sp>
-        <p:nvSpPr>
-          <p:cNvPr id="3" name="TextBox 2"/>
-          <p:cNvSpPr txBox="1"/>
-          <p:nvPr/>
-        </p:nvSpPr>
-        <p:spPr>
-          <a:xfrm>
-            <a:off x="777240" y="548640"/>
-            <a:ext cx="10607040" cy="822960"/>
-          </a:xfrm>
-          <a:prstGeom prst="rect">
-            <a:avLst/>
-          </a:prstGeom>
-          <a:noFill/>
-        </p:spPr>
-        <p:txBody>
-          <a:bodyPr wrap="square" lIns="0" rIns="0" tIns="0" bIns="0">
-            <a:spAutoFit/>
-          </a:bodyPr>
-          <a:lstStyle/>
-          <a:p>
-            <a:pPr algn="l">
-              <a:spcAft>
-                <a:spcPts val="600"/>
-              </a:spcAft>
-            </a:pPr>
-            <a:r>
-              <a:rPr sz="3400" b="1">
-                <a:solidFill>
-                  <a:srgbClr val="131E19"/>
-                </a:solidFill>
-                <a:latin typeface="Helvetica Neue"/>
-              </a:rPr>
-              <a:t>Ishonchlilik</a:t>
-            </a:r>
-          </a:p>
-        </p:txBody>
-      </p:sp>
-      <p:sp>
-        <p:nvSpPr>
-          <p:cNvPr id="4" name="Rounded Rectangle 3"/>
-          <p:cNvSpPr/>
-          <p:nvPr/>
-        </p:nvSpPr>
-        <p:spPr>
-          <a:xfrm>
-            <a:off x="777240" y="2194560"/>
-            <a:ext cx="3383280" cy="2286000"/>
-          </a:xfrm>
-          <a:prstGeom prst="roundRect">
-            <a:avLst/>
-          </a:prstGeom>
-          <a:solidFill>
-            <a:srgbClr val="FFFFFF"/>
-          </a:solidFill>
-          <a:ln w="9525">
-            <a:solidFill>
-              <a:srgbClr val="D9E0DA"/>
-            </a:solidFill>
-          </a:ln>
-          <a:effectLst/>
-        </p:spPr>
-        <p:style>
-          <a:lnRef idx="1">
-            <a:schemeClr val="accent1"/>
-          </a:lnRef>
-          <a:fillRef idx="3">
-            <a:schemeClr val="accent1"/>
-          </a:fillRef>
-          <a:effectRef idx="2">
-            <a:schemeClr val="accent1"/>
-          </a:effectRef>
-          <a:fontRef idx="minor">
-            <a:schemeClr val="lt1"/>
-          </a:fontRef>
-        </p:style>
-        <p:txBody>
-          <a:bodyPr rtlCol="0" anchor="ctr"/>
-          <a:lstStyle/>
-          <a:p>
-            <a:pPr algn="ctr"/>
-          </a:p>
-        </p:txBody>
-      </p:sp>
-      <p:sp>
-        <p:nvSpPr>
-          <p:cNvPr id="5" name="Rounded Rectangle 4"/>
-          <p:cNvSpPr/>
-          <p:nvPr/>
-        </p:nvSpPr>
-        <p:spPr>
-          <a:xfrm>
-            <a:off x="777240" y="2194560"/>
-            <a:ext cx="64008" cy="2286000"/>
-          </a:xfrm>
-          <a:prstGeom prst="roundRect">
-            <a:avLst/>
-          </a:prstGeom>
-          <a:solidFill>
-            <a:srgbClr val="0E6B58"/>
-          </a:solidFill>
-          <a:ln>
-            <a:noFill/>
-          </a:ln>
-          <a:effectLst/>
-        </p:spPr>
-        <p:style>
-          <a:lnRef idx="1">
-            <a:schemeClr val="accent1"/>
-          </a:lnRef>
-          <a:fillRef idx="3">
-            <a:schemeClr val="accent1"/>
-          </a:fillRef>
-          <a:effectRef idx="2">
-            <a:schemeClr val="accent1"/>
-          </a:effectRef>
-          <a:fontRef idx="minor">
-            <a:schemeClr val="lt1"/>
-          </a:fontRef>
-        </p:style>
-        <p:txBody>
-          <a:bodyPr rtlCol="0" anchor="ctr"/>
-          <a:lstStyle/>
-          <a:p>
-            <a:pPr algn="ctr"/>
-          </a:p>
-        </p:txBody>
-      </p:sp>
-      <p:sp>
-        <p:nvSpPr>
-          <p:cNvPr id="6" name="TextBox 5"/>
-          <p:cNvSpPr txBox="1"/>
-          <p:nvPr/>
-        </p:nvSpPr>
-        <p:spPr>
-          <a:xfrm>
-            <a:off x="1143000" y="2560320"/>
-            <a:ext cx="2743200" cy="731520"/>
-          </a:xfrm>
-          <a:prstGeom prst="rect">
-            <a:avLst/>
-          </a:prstGeom>
-          <a:noFill/>
-        </p:spPr>
-        <p:txBody>
-          <a:bodyPr wrap="square" lIns="0" rIns="0" tIns="0" bIns="0">
-            <a:spAutoFit/>
-          </a:bodyPr>
-          <a:lstStyle/>
-          <a:p>
-            <a:pPr algn="l">
-              <a:spcAft>
-                <a:spcPts val="600"/>
-              </a:spcAft>
-            </a:pPr>
-            <a:r>
-              <a:rPr sz="3800" b="1">
-                <a:solidFill>
-                  <a:srgbClr val="0E6B58"/>
-                </a:solidFill>
-                <a:latin typeface="Helvetica Neue"/>
-              </a:rPr>
-              <a:t>51</a:t>
-            </a:r>
-          </a:p>
-        </p:txBody>
-      </p:sp>
-      <p:sp>
-        <p:nvSpPr>
-          <p:cNvPr id="7" name="TextBox 6"/>
-          <p:cNvSpPr txBox="1"/>
-          <p:nvPr/>
-        </p:nvSpPr>
-        <p:spPr>
-          <a:xfrm>
-            <a:off x="1143000" y="3291840"/>
-            <a:ext cx="2743200" cy="365760"/>
-          </a:xfrm>
-          <a:prstGeom prst="rect">
-            <a:avLst/>
-          </a:prstGeom>
-          <a:noFill/>
-        </p:spPr>
-        <p:txBody>
-          <a:bodyPr wrap="square" lIns="0" rIns="0" tIns="0" bIns="0">
-            <a:spAutoFit/>
-          </a:bodyPr>
-          <a:lstStyle/>
-          <a:p>
-            <a:pPr algn="l">
-              <a:spcAft>
-                <a:spcPts val="600"/>
-              </a:spcAft>
-            </a:pPr>
-            <a:r>
-              <a:rPr sz="1700" b="1">
-                <a:solidFill>
-                  <a:srgbClr val="131E19"/>
-                </a:solidFill>
-                <a:latin typeface="Helvetica Neue"/>
-              </a:rPr>
-              <a:t>avtomatik test</a:t>
-            </a:r>
-          </a:p>
-        </p:txBody>
-      </p:sp>
-      <p:sp>
-        <p:nvSpPr>
-          <p:cNvPr id="8" name="TextBox 7"/>
-          <p:cNvSpPr txBox="1"/>
-          <p:nvPr/>
-        </p:nvSpPr>
-        <p:spPr>
-          <a:xfrm>
-            <a:off x="1143000" y="3703320"/>
-            <a:ext cx="2743200" cy="640080"/>
-          </a:xfrm>
-          <a:prstGeom prst="rect">
-            <a:avLst/>
-          </a:prstGeom>
-          <a:noFill/>
-        </p:spPr>
-        <p:txBody>
-          <a:bodyPr wrap="square" lIns="0" rIns="0" tIns="0" bIns="0">
-            <a:spAutoFit/>
-          </a:bodyPr>
-          <a:lstStyle/>
-          <a:p>
-            <a:pPr algn="l">
-              <a:spcAft>
-                <a:spcPts val="600"/>
-              </a:spcAft>
-            </a:pPr>
-            <a:r>
-              <a:rPr sz="1300" b="0">
-                <a:solidFill>
-                  <a:srgbClr val="6E7D76"/>
-                </a:solidFill>
-                <a:latin typeface="Helvetica Neue"/>
-              </a:rPr>
-              <a:t>Har biri topilgan xatoni qaytishidan saqlaydi</a:t>
-            </a:r>
-          </a:p>
-        </p:txBody>
-      </p:sp>
-      <p:sp>
-        <p:nvSpPr>
-          <p:cNvPr id="9" name="Rounded Rectangle 8"/>
-          <p:cNvSpPr/>
-          <p:nvPr/>
-        </p:nvSpPr>
-        <p:spPr>
-          <a:xfrm>
-            <a:off x="4389120" y="2194560"/>
-            <a:ext cx="3383280" cy="2286000"/>
-          </a:xfrm>
-          <a:prstGeom prst="roundRect">
-            <a:avLst/>
-          </a:prstGeom>
-          <a:solidFill>
-            <a:srgbClr val="FFFFFF"/>
-          </a:solidFill>
-          <a:ln w="9525">
-            <a:solidFill>
-              <a:srgbClr val="D9E0DA"/>
-            </a:solidFill>
-          </a:ln>
-          <a:effectLst/>
-        </p:spPr>
-        <p:style>
-          <a:lnRef idx="1">
-            <a:schemeClr val="accent1"/>
-          </a:lnRef>
-          <a:fillRef idx="3">
-            <a:schemeClr val="accent1"/>
-          </a:fillRef>
-          <a:effectRef idx="2">
-            <a:schemeClr val="accent1"/>
-          </a:effectRef>
-          <a:fontRef idx="minor">
-            <a:schemeClr val="lt1"/>
-          </a:fontRef>
-        </p:style>
-        <p:txBody>
-          <a:bodyPr rtlCol="0" anchor="ctr"/>
-          <a:lstStyle/>
-          <a:p>
-            <a:pPr algn="ctr"/>
-          </a:p>
-        </p:txBody>
-      </p:sp>
-      <p:sp>
-        <p:nvSpPr>
-          <p:cNvPr id="10" name="Rounded Rectangle 9"/>
-          <p:cNvSpPr/>
-          <p:nvPr/>
-        </p:nvSpPr>
-        <p:spPr>
-          <a:xfrm>
-            <a:off x="4389120" y="2194560"/>
-            <a:ext cx="64008" cy="2286000"/>
-          </a:xfrm>
-          <a:prstGeom prst="roundRect">
-            <a:avLst/>
-          </a:prstGeom>
-          <a:solidFill>
-            <a:srgbClr val="0E6B58"/>
-          </a:solidFill>
-          <a:ln>
-            <a:noFill/>
-          </a:ln>
-          <a:effectLst/>
-        </p:spPr>
-        <p:style>
-          <a:lnRef idx="1">
-            <a:schemeClr val="accent1"/>
-          </a:lnRef>
-          <a:fillRef idx="3">
-            <a:schemeClr val="accent1"/>
-          </a:fillRef>
-          <a:effectRef idx="2">
-            <a:schemeClr val="accent1"/>
-          </a:effectRef>
-          <a:fontRef idx="minor">
-            <a:schemeClr val="lt1"/>
-          </a:fontRef>
-        </p:style>
-        <p:txBody>
-          <a:bodyPr rtlCol="0" anchor="ctr"/>
-          <a:lstStyle/>
-          <a:p>
-            <a:pPr algn="ctr"/>
-          </a:p>
-        </p:txBody>
-      </p:sp>
-      <p:sp>
-        <p:nvSpPr>
-          <p:cNvPr id="11" name="TextBox 10"/>
-          <p:cNvSpPr txBox="1"/>
-          <p:nvPr/>
-        </p:nvSpPr>
-        <p:spPr>
-          <a:xfrm>
-            <a:off x="4754880" y="2560320"/>
-            <a:ext cx="2743200" cy="731520"/>
-          </a:xfrm>
-          <a:prstGeom prst="rect">
-            <a:avLst/>
-          </a:prstGeom>
-          <a:noFill/>
-        </p:spPr>
-        <p:txBody>
-          <a:bodyPr wrap="square" lIns="0" rIns="0" tIns="0" bIns="0">
-            <a:spAutoFit/>
-          </a:bodyPr>
-          <a:lstStyle/>
-          <a:p>
-            <a:pPr algn="l">
-              <a:spcAft>
-                <a:spcPts val="600"/>
-              </a:spcAft>
-            </a:pPr>
-            <a:r>
-              <a:rPr sz="3800" b="1">
-                <a:solidFill>
-                  <a:srgbClr val="0E6B58"/>
-                </a:solidFill>
-                <a:latin typeface="Helvetica Neue"/>
-              </a:rPr>
-              <a:t>100%</a:t>
-            </a:r>
-          </a:p>
-        </p:txBody>
-      </p:sp>
-      <p:sp>
-        <p:nvSpPr>
-          <p:cNvPr id="12" name="TextBox 11"/>
-          <p:cNvSpPr txBox="1"/>
-          <p:nvPr/>
-        </p:nvSpPr>
-        <p:spPr>
-          <a:xfrm>
-            <a:off x="4754880" y="3291840"/>
-            <a:ext cx="2743200" cy="365760"/>
-          </a:xfrm>
-          <a:prstGeom prst="rect">
-            <a:avLst/>
-          </a:prstGeom>
-          <a:noFill/>
-        </p:spPr>
-        <p:txBody>
-          <a:bodyPr wrap="square" lIns="0" rIns="0" tIns="0" bIns="0">
-            <a:spAutoFit/>
-          </a:bodyPr>
-          <a:lstStyle/>
-          <a:p>
-            <a:pPr algn="l">
-              <a:spcAft>
-                <a:spcPts val="600"/>
-              </a:spcAft>
-            </a:pPr>
-            <a:r>
-              <a:rPr sz="1700" b="1">
-                <a:solidFill>
-                  <a:srgbClr val="131E19"/>
-                </a:solidFill>
-                <a:latin typeface="Helvetica Neue"/>
-              </a:rPr>
-              <a:t>shifokor nazorati</a:t>
-            </a:r>
-          </a:p>
-        </p:txBody>
-      </p:sp>
-      <p:sp>
-        <p:nvSpPr>
-          <p:cNvPr id="13" name="TextBox 12"/>
-          <p:cNvSpPr txBox="1"/>
-          <p:nvPr/>
-        </p:nvSpPr>
-        <p:spPr>
-          <a:xfrm>
-            <a:off x="4754880" y="3703320"/>
-            <a:ext cx="2743200" cy="640080"/>
-          </a:xfrm>
-          <a:prstGeom prst="rect">
-            <a:avLst/>
-          </a:prstGeom>
-          <a:noFill/>
-        </p:spPr>
-        <p:txBody>
-          <a:bodyPr wrap="square" lIns="0" rIns="0" tIns="0" bIns="0">
-            <a:spAutoFit/>
-          </a:bodyPr>
-          <a:lstStyle/>
-          <a:p>
-            <a:pPr algn="l">
-              <a:spcAft>
-                <a:spcPts val="600"/>
-              </a:spcAft>
-            </a:pPr>
-            <a:r>
-              <a:rPr sz="1300" b="0">
-                <a:solidFill>
-                  <a:srgbClr val="6E7D76"/>
-                </a:solidFill>
-                <a:latin typeface="Helvetica Neue"/>
-              </a:rPr>
-              <a:t>Past ishonchli taklif o'zi yoqilmaydi</a:t>
-            </a:r>
-          </a:p>
-        </p:txBody>
-      </p:sp>
-      <p:sp>
-        <p:nvSpPr>
-          <p:cNvPr id="14" name="Rounded Rectangle 13"/>
-          <p:cNvSpPr/>
-          <p:nvPr/>
-        </p:nvSpPr>
-        <p:spPr>
-          <a:xfrm>
-            <a:off x="8001000" y="2194560"/>
-            <a:ext cx="3383280" cy="2286000"/>
-          </a:xfrm>
-          <a:prstGeom prst="roundRect">
-            <a:avLst/>
-          </a:prstGeom>
-          <a:solidFill>
-            <a:srgbClr val="FFFFFF"/>
-          </a:solidFill>
-          <a:ln w="9525">
-            <a:solidFill>
-              <a:srgbClr val="D9E0DA"/>
-            </a:solidFill>
-          </a:ln>
-          <a:effectLst/>
-        </p:spPr>
-        <p:style>
-          <a:lnRef idx="1">
-            <a:schemeClr val="accent1"/>
-          </a:lnRef>
-          <a:fillRef idx="3">
-            <a:schemeClr val="accent1"/>
-          </a:fillRef>
-          <a:effectRef idx="2">
-            <a:schemeClr val="accent1"/>
-          </a:effectRef>
-          <a:fontRef idx="minor">
-            <a:schemeClr val="lt1"/>
-          </a:fontRef>
-        </p:style>
-        <p:txBody>
-          <a:bodyPr rtlCol="0" anchor="ctr"/>
-          <a:lstStyle/>
-          <a:p>
-            <a:pPr algn="ctr"/>
-          </a:p>
-        </p:txBody>
-      </p:sp>
-      <p:sp>
-        <p:nvSpPr>
-          <p:cNvPr id="15" name="Rounded Rectangle 14"/>
-          <p:cNvSpPr/>
-          <p:nvPr/>
-        </p:nvSpPr>
-        <p:spPr>
-          <a:xfrm>
-            <a:off x="8001000" y="2194560"/>
-            <a:ext cx="64008" cy="2286000"/>
-          </a:xfrm>
-          <a:prstGeom prst="roundRect">
-            <a:avLst/>
-          </a:prstGeom>
-          <a:solidFill>
-            <a:srgbClr val="0E6B58"/>
-          </a:solidFill>
-          <a:ln>
-            <a:noFill/>
-          </a:ln>
-          <a:effectLst/>
-        </p:spPr>
-        <p:style>
-          <a:lnRef idx="1">
-            <a:schemeClr val="accent1"/>
-          </a:lnRef>
-          <a:fillRef idx="3">
-            <a:schemeClr val="accent1"/>
-          </a:fillRef>
-          <a:effectRef idx="2">
-            <a:schemeClr val="accent1"/>
-          </a:effectRef>
-          <a:fontRef idx="minor">
-            <a:schemeClr val="lt1"/>
-          </a:fontRef>
-        </p:style>
-        <p:txBody>
-          <a:bodyPr rtlCol="0" anchor="ctr"/>
-          <a:lstStyle/>
-          <a:p>
-            <a:pPr algn="ctr"/>
-          </a:p>
-        </p:txBody>
-      </p:sp>
-      <p:sp>
-        <p:nvSpPr>
-          <p:cNvPr id="16" name="TextBox 15"/>
-          <p:cNvSpPr txBox="1"/>
-          <p:nvPr/>
-        </p:nvSpPr>
-        <p:spPr>
-          <a:xfrm>
-            <a:off x="8366760" y="2560320"/>
-            <a:ext cx="2743200" cy="731520"/>
-          </a:xfrm>
-          <a:prstGeom prst="rect">
-            <a:avLst/>
-          </a:prstGeom>
-          <a:noFill/>
-        </p:spPr>
-        <p:txBody>
-          <a:bodyPr wrap="square" lIns="0" rIns="0" tIns="0" bIns="0">
-            <a:spAutoFit/>
-          </a:bodyPr>
-          <a:lstStyle/>
-          <a:p>
-            <a:pPr algn="l">
-              <a:spcAft>
-                <a:spcPts val="600"/>
+                <a:spcPts val="700"/>
               </a:spcAft>
             </a:pPr>
             <a:r>
@@ -6491,7 +5800,7 @@
         </p:nvSpPr>
         <p:spPr>
           <a:xfrm>
-            <a:off x="8366760" y="3291840"/>
+            <a:off x="8385048" y="3364992"/>
             <a:ext cx="2743200" cy="365760"/>
           </a:xfrm>
           <a:prstGeom prst="rect">
@@ -6507,7 +5816,7 @@
           <a:p>
             <a:pPr algn="l">
               <a:spcAft>
-                <a:spcPts val="600"/>
+                <a:spcPts val="700"/>
               </a:spcAft>
             </a:pPr>
             <a:r>
@@ -6530,7 +5839,7 @@
         </p:nvSpPr>
         <p:spPr>
           <a:xfrm>
-            <a:off x="8366760" y="3703320"/>
+            <a:off x="8385048" y="3767328"/>
             <a:ext cx="2743200" cy="640080"/>
           </a:xfrm>
           <a:prstGeom prst="rect">
@@ -6546,7 +5855,7 @@
           <a:p>
             <a:pPr algn="l">
               <a:spcAft>
-                <a:spcPts val="600"/>
+                <a:spcPts val="700"/>
               </a:spcAft>
             </a:pPr>
             <a:r>
@@ -6556,7 +5865,7 @@
                 </a:solidFill>
                 <a:latin typeface="Helvetica Neue"/>
               </a:rPr>
-              <a:t>Audio ham, matn ham qurilmadan chiqmaydi</a:t>
+              <a:t>Audio ham, matn ham qurilmada qoladi</a:t>
             </a:r>
           </a:p>
         </p:txBody>
@@ -6569,7 +5878,7 @@
         </p:nvSpPr>
         <p:spPr>
           <a:xfrm>
-            <a:off x="777240" y="5029200"/>
+            <a:off x="777240" y="5074920"/>
             <a:ext cx="10607040" cy="914400"/>
           </a:xfrm>
           <a:prstGeom prst="rect">
@@ -6585,17 +5894,56 @@
           <a:p>
             <a:pPr algn="l">
               <a:spcAft>
-                <a:spcPts val="600"/>
+                <a:spcPts val="700"/>
               </a:spcAft>
             </a:pPr>
             <a:r>
-              <a:rPr sz="1900" b="0">
+              <a:rPr sz="2000" b="0">
                 <a:solidFill>
                   <a:srgbClr val="131E19"/>
                 </a:solidFill>
                 <a:latin typeface="Helvetica Neue"/>
               </a:rPr>
-              <a:t>Xato topilganda test yoziladi. Shuning uchun bir marta tuzatilgan narsa qaytib kelmaydi.</a:t>
+              <a:t>Ovozdan formagacha bo'lgan butun yo'l tayyor va sinovdan o'tgan.</a:t>
+            </a:r>
+          </a:p>
+        </p:txBody>
+      </p:sp>
+      <p:sp>
+        <p:nvSpPr>
+          <p:cNvPr id="20" name="TextBox 19"/>
+          <p:cNvSpPr txBox="1"/>
+          <p:nvPr/>
+        </p:nvSpPr>
+        <p:spPr>
+          <a:xfrm>
+            <a:off x="777240" y="6035040"/>
+            <a:ext cx="10607040" cy="365760"/>
+          </a:xfrm>
+          <a:prstGeom prst="rect">
+            <a:avLst/>
+          </a:prstGeom>
+          <a:noFill/>
+        </p:spPr>
+        <p:txBody>
+          <a:bodyPr wrap="square" lIns="0" rIns="0" tIns="0" bIns="0">
+            <a:spAutoFit/>
+          </a:bodyPr>
+          <a:lstStyle/>
+          <a:p>
+            <a:pPr algn="l">
+              <a:spcAft>
+                <a:spcPts val="700"/>
+              </a:spcAft>
+            </a:pPr>
+            <a:r>
+              <a:rPr sz="1500" b="1">
+                <a:solidFill>
+                  <a:srgbClr val="0E6B58"/>
+                </a:solidFill>
+                <a:latin typeface="Helvetica Neue"/>
+              </a:rPr>
+              <a:t>github.com/VohidovTohirjon/voice-to-text-openemr</a:t>
             </a:r>
           </a:p>
         </p:txBody>

</xml_diff>